<commit_message>
A4 PPT resume matching HTML style
</commit_message>
<xml_diff>
--- a/docs/resume.pptx
+++ b/docs/resume.pptx
@@ -7,15 +7,8 @@
   <p:sldIdLst>
     <p:sldId id="256" r:id="rId7"/>
     <p:sldId id="257" r:id="rId8"/>
-    <p:sldId id="258" r:id="rId9"/>
-    <p:sldId id="259" r:id="rId10"/>
-    <p:sldId id="260" r:id="rId11"/>
-    <p:sldId id="261" r:id="rId12"/>
-    <p:sldId id="262" r:id="rId13"/>
-    <p:sldId id="263" r:id="rId14"/>
-    <p:sldId id="264" r:id="rId15"/>
   </p:sldIdLst>
-  <p:sldSz cx="12191695" cy="6858000" type="screen4x3"/>
+  <p:sldSz cx="7560000" cy="10692000" type="screen4x3"/>
   <p:notesSz cx="6858000" cy="9144000"/>
   <p:defaultTextStyle>
     <a:defPPr>
@@ -3112,14 +3105,14 @@
         </p:nvSpPr>
         <p:spPr>
           <a:xfrm>
-            <a:off x="0" y="2560320"/>
-            <a:ext cx="12191695" cy="54864"/>
+            <a:off x="0" y="0"/>
+            <a:ext cx="7560000" cy="1080000"/>
           </a:xfrm>
           <a:prstGeom prst="rect">
             <a:avLst/>
           </a:prstGeom>
           <a:solidFill>
-            <a:srgbClr val="5A9A5A"/>
+            <a:srgbClr val="1A1A2E"/>
           </a:solidFill>
           <a:ln>
             <a:noFill/>
@@ -3155,8 +3148,8 @@
         </p:nvSpPr>
         <p:spPr>
           <a:xfrm>
-            <a:off x="731520" y="1097280"/>
-            <a:ext cx="10058400" cy="1097280"/>
+            <a:off x="540000" y="216000"/>
+            <a:ext cx="6480000" cy="360000"/>
           </a:xfrm>
           <a:prstGeom prst="rect">
             <a:avLst/>
@@ -3169,15 +3162,15 @@
           </a:bodyPr>
           <a:lstStyle/>
           <a:p>
-            <a:pPr>
-              <a:defRPr sz="4800" b="1">
-                <a:solidFill>
-                  <a:srgbClr val="1A1A1A"/>
+            <a:pPr algn="l">
+              <a:defRPr sz="2200" b="1">
+                <a:solidFill>
+                  <a:srgbClr val="FFFFFF"/>
                 </a:solidFill>
               </a:defRPr>
             </a:pPr>
             <a:r>
-              <a:t>个人简历</a:t>
+              <a:t>AIGC内容创作 / AI科技自媒体团队成员</a:t>
             </a:r>
           </a:p>
         </p:txBody>
@@ -3190,8 +3183,8 @@
         </p:nvSpPr>
         <p:spPr>
           <a:xfrm>
-            <a:off x="731520" y="2011680"/>
-            <a:ext cx="10058400" cy="548640"/>
+            <a:off x="540000" y="576000"/>
+            <a:ext cx="6480000" cy="216000"/>
           </a:xfrm>
           <a:prstGeom prst="rect">
             <a:avLst/>
@@ -3204,29 +3197,72 @@
           </a:bodyPr>
           <a:lstStyle/>
           <a:p>
-            <a:pPr>
-              <a:defRPr sz="2200" b="0">
-                <a:solidFill>
-                  <a:srgbClr val="5A9A5A"/>
+            <a:pPr algn="l">
+              <a:defRPr sz="1200" b="0">
+                <a:solidFill>
+                  <a:srgbClr val="CCCCDD"/>
                 </a:solidFill>
               </a:defRPr>
             </a:pPr>
             <a:r>
-              <a:t>AIGC内容创作 / AI科技自媒体团队成员</a:t>
-            </a:r>
-          </a:p>
-        </p:txBody>
-      </p:sp>
-      <p:sp>
-        <p:nvSpPr>
-          <p:cNvPr id="5" name="TextBox 4"/>
+              <a:t>AIGC内容创作 · AI科技自媒体 · 深圳 · 15-20K</a:t>
+            </a:r>
+          </a:p>
+        </p:txBody>
+      </p:sp>
+      <p:sp>
+        <p:nvSpPr>
+          <p:cNvPr id="5" name="Rectangle 4"/>
+          <p:cNvSpPr/>
+          <p:nvPr/>
+        </p:nvSpPr>
+        <p:spPr>
+          <a:xfrm>
+            <a:off x="5940000" y="216000"/>
+            <a:ext cx="1007999" cy="1368000"/>
+          </a:xfrm>
+          <a:prstGeom prst="rect">
+            <a:avLst/>
+          </a:prstGeom>
+          <a:solidFill>
+            <a:srgbClr val="252540"/>
+          </a:solidFill>
+          <a:ln>
+            <a:noFill/>
+          </a:ln>
+        </p:spPr>
+        <p:style>
+          <a:lnRef idx="1">
+            <a:schemeClr val="accent1"/>
+          </a:lnRef>
+          <a:fillRef idx="3">
+            <a:schemeClr val="accent1"/>
+          </a:fillRef>
+          <a:effectRef idx="2">
+            <a:schemeClr val="accent1"/>
+          </a:effectRef>
+          <a:fontRef idx="minor">
+            <a:schemeClr val="lt1"/>
+          </a:fontRef>
+        </p:style>
+        <p:txBody>
+          <a:bodyPr rtlCol="0" anchor="ctr"/>
+          <a:lstStyle/>
+          <a:p>
+            <a:pPr algn="ctr"/>
+          </a:p>
+        </p:txBody>
+      </p:sp>
+      <p:sp>
+        <p:nvSpPr>
+          <p:cNvPr id="6" name="TextBox 5"/>
           <p:cNvSpPr txBox="1"/>
           <p:nvPr/>
         </p:nvSpPr>
         <p:spPr>
           <a:xfrm>
-            <a:off x="731520" y="2926080"/>
-            <a:ext cx="10058400" cy="731520"/>
+            <a:off x="5940000" y="720000"/>
+            <a:ext cx="1007999" cy="180000"/>
           </a:xfrm>
           <a:prstGeom prst="rect">
             <a:avLst/>
@@ -3239,29 +3275,72 @@
           </a:bodyPr>
           <a:lstStyle/>
           <a:p>
-            <a:pPr>
-              <a:defRPr sz="1400" b="0">
-                <a:solidFill>
-                  <a:srgbClr val="555555"/>
+            <a:pPr algn="ctr">
+              <a:defRPr sz="1000" b="0">
+                <a:solidFill>
+                  <a:srgbClr val="888899"/>
                 </a:solidFill>
               </a:defRPr>
             </a:pPr>
             <a:r>
-              <a:t>3年AIGC行业实践者，专注AI内容生产自动化与工作流产品化。主导搭建70+ComfyUI工作流库，实现模型使用量80K+；独立开发AI长篇小说写作系统与视频笔记机器人，具备从模型训练到Agent应用的全链路落地能力。寻求AI科技自媒体或A</a:t>
-            </a:r>
-          </a:p>
-        </p:txBody>
-      </p:sp>
-      <p:sp>
-        <p:nvSpPr>
-          <p:cNvPr id="6" name="TextBox 5"/>
+              <a:t>证件照</a:t>
+            </a:r>
+          </a:p>
+        </p:txBody>
+      </p:sp>
+      <p:sp>
+        <p:nvSpPr>
+          <p:cNvPr id="7" name="Rectangle 6"/>
+          <p:cNvSpPr/>
+          <p:nvPr/>
+        </p:nvSpPr>
+        <p:spPr>
+          <a:xfrm>
+            <a:off x="540000" y="1260000"/>
+            <a:ext cx="54000" cy="251999"/>
+          </a:xfrm>
+          <a:prstGeom prst="rect">
+            <a:avLst/>
+          </a:prstGeom>
+          <a:solidFill>
+            <a:srgbClr val="5A9A5A"/>
+          </a:solidFill>
+          <a:ln>
+            <a:noFill/>
+          </a:ln>
+        </p:spPr>
+        <p:style>
+          <a:lnRef idx="1">
+            <a:schemeClr val="accent1"/>
+          </a:lnRef>
+          <a:fillRef idx="3">
+            <a:schemeClr val="accent1"/>
+          </a:fillRef>
+          <a:effectRef idx="2">
+            <a:schemeClr val="accent1"/>
+          </a:effectRef>
+          <a:fontRef idx="minor">
+            <a:schemeClr val="lt1"/>
+          </a:fontRef>
+        </p:style>
+        <p:txBody>
+          <a:bodyPr rtlCol="0" anchor="ctr"/>
+          <a:lstStyle/>
+          <a:p>
+            <a:pPr algn="ctr"/>
+          </a:p>
+        </p:txBody>
+      </p:sp>
+      <p:sp>
+        <p:nvSpPr>
+          <p:cNvPr id="8" name="TextBox 7"/>
           <p:cNvSpPr txBox="1"/>
           <p:nvPr/>
         </p:nvSpPr>
         <p:spPr>
           <a:xfrm>
-            <a:off x="731520" y="5029200"/>
-            <a:ext cx="4572000" cy="365760"/>
+            <a:off x="684000" y="1278000"/>
+            <a:ext cx="6480000" cy="216000"/>
           </a:xfrm>
           <a:prstGeom prst="rect">
             <a:avLst/>
@@ -3274,15 +3353,1287 @@
           </a:bodyPr>
           <a:lstStyle/>
           <a:p>
+            <a:pPr algn="l">
+              <a:defRPr sz="1500" b="1">
+                <a:solidFill>
+                  <a:srgbClr val="1A1A1A"/>
+                </a:solidFill>
+              </a:defRPr>
+            </a:pPr>
+            <a:r>
+              <a:t>个人概述</a:t>
+            </a:r>
+          </a:p>
+        </p:txBody>
+      </p:sp>
+      <p:sp>
+        <p:nvSpPr>
+          <p:cNvPr id="9" name="TextBox 8"/>
+          <p:cNvSpPr txBox="1"/>
+          <p:nvPr/>
+        </p:nvSpPr>
+        <p:spPr>
+          <a:xfrm>
+            <a:off x="540000" y="1584000"/>
+            <a:ext cx="6480000" cy="540000"/>
+          </a:xfrm>
+          <a:prstGeom prst="rect">
+            <a:avLst/>
+          </a:prstGeom>
+          <a:noFill/>
+        </p:spPr>
+        <p:txBody>
+          <a:bodyPr wrap="square">
+            <a:spAutoFit/>
+          </a:bodyPr>
+          <a:lstStyle/>
+          <a:p>
             <a:pPr>
-              <a:defRPr sz="1300" b="0">
+              <a:spcAft>
+                <a:spcPts val="400"/>
+              </a:spcAft>
+              <a:defRPr sz="1100">
                 <a:solidFill>
                   <a:srgbClr val="555555"/>
                 </a:solidFill>
               </a:defRPr>
             </a:pPr>
             <a:r>
-              <a:t>深圳 · 15-20K · 全职</a:t>
+              <a:t>3年AIGC行业实践者，专注AI内容生产自动化与工作流产品化。主导搭建70+ComfyUI工作流库，实现模型使用量80K+；独立开发AI长篇小说写作系统与视频笔记机器人，具备从模型训练到Agent应用的全链路落地能力。寻求AI科技自媒体或AIGC内容创作岗位，用技术驱动内容规模化增长。</a:t>
+            </a:r>
+          </a:p>
+        </p:txBody>
+      </p:sp>
+      <p:sp>
+        <p:nvSpPr>
+          <p:cNvPr id="10" name="Rectangle 9"/>
+          <p:cNvSpPr/>
+          <p:nvPr/>
+        </p:nvSpPr>
+        <p:spPr>
+          <a:xfrm>
+            <a:off x="540000" y="2232000"/>
+            <a:ext cx="54000" cy="251999"/>
+          </a:xfrm>
+          <a:prstGeom prst="rect">
+            <a:avLst/>
+          </a:prstGeom>
+          <a:solidFill>
+            <a:srgbClr val="5A9A5A"/>
+          </a:solidFill>
+          <a:ln>
+            <a:noFill/>
+          </a:ln>
+        </p:spPr>
+        <p:style>
+          <a:lnRef idx="1">
+            <a:schemeClr val="accent1"/>
+          </a:lnRef>
+          <a:fillRef idx="3">
+            <a:schemeClr val="accent1"/>
+          </a:fillRef>
+          <a:effectRef idx="2">
+            <a:schemeClr val="accent1"/>
+          </a:effectRef>
+          <a:fontRef idx="minor">
+            <a:schemeClr val="lt1"/>
+          </a:fontRef>
+        </p:style>
+        <p:txBody>
+          <a:bodyPr rtlCol="0" anchor="ctr"/>
+          <a:lstStyle/>
+          <a:p>
+            <a:pPr algn="ctr"/>
+          </a:p>
+        </p:txBody>
+      </p:sp>
+      <p:sp>
+        <p:nvSpPr>
+          <p:cNvPr id="11" name="TextBox 10"/>
+          <p:cNvSpPr txBox="1"/>
+          <p:nvPr/>
+        </p:nvSpPr>
+        <p:spPr>
+          <a:xfrm>
+            <a:off x="684000" y="2250000"/>
+            <a:ext cx="6480000" cy="216000"/>
+          </a:xfrm>
+          <a:prstGeom prst="rect">
+            <a:avLst/>
+          </a:prstGeom>
+          <a:noFill/>
+        </p:spPr>
+        <p:txBody>
+          <a:bodyPr wrap="square">
+            <a:spAutoFit/>
+          </a:bodyPr>
+          <a:lstStyle/>
+          <a:p>
+            <a:pPr algn="l">
+              <a:defRPr sz="1500" b="1">
+                <a:solidFill>
+                  <a:srgbClr val="1A1A1A"/>
+                </a:solidFill>
+              </a:defRPr>
+            </a:pPr>
+            <a:r>
+              <a:t>核心技能</a:t>
+            </a:r>
+          </a:p>
+        </p:txBody>
+      </p:sp>
+      <p:sp>
+        <p:nvSpPr>
+          <p:cNvPr id="12" name="TextBox 11"/>
+          <p:cNvSpPr txBox="1"/>
+          <p:nvPr/>
+        </p:nvSpPr>
+        <p:spPr>
+          <a:xfrm>
+            <a:off x="540000" y="2556000"/>
+            <a:ext cx="648000" cy="180000"/>
+          </a:xfrm>
+          <a:prstGeom prst="rect">
+            <a:avLst/>
+          </a:prstGeom>
+          <a:noFill/>
+        </p:spPr>
+        <p:txBody>
+          <a:bodyPr wrap="square">
+            <a:spAutoFit/>
+          </a:bodyPr>
+          <a:lstStyle/>
+          <a:p>
+            <a:pPr algn="l">
+              <a:defRPr sz="1100" b="1">
+                <a:solidFill>
+                  <a:srgbClr val="1A1A1A"/>
+                </a:solidFill>
+              </a:defRPr>
+            </a:pPr>
+            <a:r>
+              <a:t>精通</a:t>
+            </a:r>
+          </a:p>
+        </p:txBody>
+      </p:sp>
+      <p:sp>
+        <p:nvSpPr>
+          <p:cNvPr id="13" name="Rectangle 12"/>
+          <p:cNvSpPr/>
+          <p:nvPr/>
+        </p:nvSpPr>
+        <p:spPr>
+          <a:xfrm>
+            <a:off x="1332000" y="2574000"/>
+            <a:ext cx="2707200" cy="180000"/>
+          </a:xfrm>
+          <a:prstGeom prst="rect">
+            <a:avLst/>
+          </a:prstGeom>
+          <a:solidFill>
+            <a:srgbClr val="1A1A2E"/>
+          </a:solidFill>
+          <a:ln>
+            <a:noFill/>
+          </a:ln>
+        </p:spPr>
+        <p:style>
+          <a:lnRef idx="1">
+            <a:schemeClr val="accent1"/>
+          </a:lnRef>
+          <a:fillRef idx="3">
+            <a:schemeClr val="accent1"/>
+          </a:fillRef>
+          <a:effectRef idx="2">
+            <a:schemeClr val="accent1"/>
+          </a:effectRef>
+          <a:fontRef idx="minor">
+            <a:schemeClr val="lt1"/>
+          </a:fontRef>
+        </p:style>
+        <p:txBody>
+          <a:bodyPr rtlCol="0" anchor="ctr"/>
+          <a:lstStyle/>
+          <a:p>
+            <a:pPr algn="ctr"/>
+          </a:p>
+        </p:txBody>
+      </p:sp>
+      <p:sp>
+        <p:nvSpPr>
+          <p:cNvPr id="14" name="TextBox 13"/>
+          <p:cNvSpPr txBox="1"/>
+          <p:nvPr/>
+        </p:nvSpPr>
+        <p:spPr>
+          <a:xfrm>
+            <a:off x="1368000" y="2577600"/>
+            <a:ext cx="2635200" cy="162000"/>
+          </a:xfrm>
+          <a:prstGeom prst="rect">
+            <a:avLst/>
+          </a:prstGeom>
+          <a:noFill/>
+        </p:spPr>
+        <p:txBody>
+          <a:bodyPr wrap="square">
+            <a:spAutoFit/>
+          </a:bodyPr>
+          <a:lstStyle/>
+          <a:p>
+            <a:pPr algn="l">
+              <a:defRPr sz="900" b="0">
+                <a:solidFill>
+                  <a:srgbClr val="FFFFFF"/>
+                </a:solidFill>
+              </a:defRPr>
+            </a:pPr>
+            <a:r>
+              <a:t>Stable Diffusion</a:t>
+            </a:r>
+          </a:p>
+        </p:txBody>
+      </p:sp>
+      <p:sp>
+        <p:nvSpPr>
+          <p:cNvPr id="15" name="Rectangle 14"/>
+          <p:cNvSpPr/>
+          <p:nvPr/>
+        </p:nvSpPr>
+        <p:spPr>
+          <a:xfrm>
+            <a:off x="4111200" y="2574000"/>
+            <a:ext cx="2102400" cy="180000"/>
+          </a:xfrm>
+          <a:prstGeom prst="rect">
+            <a:avLst/>
+          </a:prstGeom>
+          <a:solidFill>
+            <a:srgbClr val="1A1A2E"/>
+          </a:solidFill>
+          <a:ln>
+            <a:noFill/>
+          </a:ln>
+        </p:spPr>
+        <p:style>
+          <a:lnRef idx="1">
+            <a:schemeClr val="accent1"/>
+          </a:lnRef>
+          <a:fillRef idx="3">
+            <a:schemeClr val="accent1"/>
+          </a:fillRef>
+          <a:effectRef idx="2">
+            <a:schemeClr val="accent1"/>
+          </a:effectRef>
+          <a:fontRef idx="minor">
+            <a:schemeClr val="lt1"/>
+          </a:fontRef>
+        </p:style>
+        <p:txBody>
+          <a:bodyPr rtlCol="0" anchor="ctr"/>
+          <a:lstStyle/>
+          <a:p>
+            <a:pPr algn="ctr"/>
+          </a:p>
+        </p:txBody>
+      </p:sp>
+      <p:sp>
+        <p:nvSpPr>
+          <p:cNvPr id="16" name="TextBox 15"/>
+          <p:cNvSpPr txBox="1"/>
+          <p:nvPr/>
+        </p:nvSpPr>
+        <p:spPr>
+          <a:xfrm>
+            <a:off x="4147200" y="2577600"/>
+            <a:ext cx="2030400" cy="162000"/>
+          </a:xfrm>
+          <a:prstGeom prst="rect">
+            <a:avLst/>
+          </a:prstGeom>
+          <a:noFill/>
+        </p:spPr>
+        <p:txBody>
+          <a:bodyPr wrap="square">
+            <a:spAutoFit/>
+          </a:bodyPr>
+          <a:lstStyle/>
+          <a:p>
+            <a:pPr algn="l">
+              <a:defRPr sz="900" b="0">
+                <a:solidFill>
+                  <a:srgbClr val="FFFFFF"/>
+                </a:solidFill>
+              </a:defRPr>
+            </a:pPr>
+            <a:r>
+              <a:t>ComfyUI工作流搭建</a:t>
+            </a:r>
+          </a:p>
+        </p:txBody>
+      </p:sp>
+      <p:sp>
+        <p:nvSpPr>
+          <p:cNvPr id="17" name="Rectangle 16"/>
+          <p:cNvSpPr/>
+          <p:nvPr/>
+        </p:nvSpPr>
+        <p:spPr>
+          <a:xfrm>
+            <a:off x="1332000" y="2825999"/>
+            <a:ext cx="1951200" cy="180000"/>
+          </a:xfrm>
+          <a:prstGeom prst="rect">
+            <a:avLst/>
+          </a:prstGeom>
+          <a:solidFill>
+            <a:srgbClr val="1A1A2E"/>
+          </a:solidFill>
+          <a:ln>
+            <a:noFill/>
+          </a:ln>
+        </p:spPr>
+        <p:style>
+          <a:lnRef idx="1">
+            <a:schemeClr val="accent1"/>
+          </a:lnRef>
+          <a:fillRef idx="3">
+            <a:schemeClr val="accent1"/>
+          </a:fillRef>
+          <a:effectRef idx="2">
+            <a:schemeClr val="accent1"/>
+          </a:effectRef>
+          <a:fontRef idx="minor">
+            <a:schemeClr val="lt1"/>
+          </a:fontRef>
+        </p:style>
+        <p:txBody>
+          <a:bodyPr rtlCol="0" anchor="ctr"/>
+          <a:lstStyle/>
+          <a:p>
+            <a:pPr algn="ctr"/>
+          </a:p>
+        </p:txBody>
+      </p:sp>
+      <p:sp>
+        <p:nvSpPr>
+          <p:cNvPr id="18" name="TextBox 17"/>
+          <p:cNvSpPr txBox="1"/>
+          <p:nvPr/>
+        </p:nvSpPr>
+        <p:spPr>
+          <a:xfrm>
+            <a:off x="1368000" y="2829599"/>
+            <a:ext cx="1879200" cy="162000"/>
+          </a:xfrm>
+          <a:prstGeom prst="rect">
+            <a:avLst/>
+          </a:prstGeom>
+          <a:noFill/>
+        </p:spPr>
+        <p:txBody>
+          <a:bodyPr wrap="square">
+            <a:spAutoFit/>
+          </a:bodyPr>
+          <a:lstStyle/>
+          <a:p>
+            <a:pPr algn="l">
+              <a:defRPr sz="900" b="0">
+                <a:solidFill>
+                  <a:srgbClr val="FFFFFF"/>
+                </a:solidFill>
+              </a:defRPr>
+            </a:pPr>
+            <a:r>
+              <a:t>LoRA模型训练与调优</a:t>
+            </a:r>
+          </a:p>
+        </p:txBody>
+      </p:sp>
+      <p:sp>
+        <p:nvSpPr>
+          <p:cNvPr id="19" name="Rectangle 18"/>
+          <p:cNvSpPr/>
+          <p:nvPr/>
+        </p:nvSpPr>
+        <p:spPr>
+          <a:xfrm>
+            <a:off x="3355200" y="2825999"/>
+            <a:ext cx="2102400" cy="180000"/>
+          </a:xfrm>
+          <a:prstGeom prst="rect">
+            <a:avLst/>
+          </a:prstGeom>
+          <a:solidFill>
+            <a:srgbClr val="1A1A2E"/>
+          </a:solidFill>
+          <a:ln>
+            <a:noFill/>
+          </a:ln>
+        </p:spPr>
+        <p:style>
+          <a:lnRef idx="1">
+            <a:schemeClr val="accent1"/>
+          </a:lnRef>
+          <a:fillRef idx="3">
+            <a:schemeClr val="accent1"/>
+          </a:fillRef>
+          <a:effectRef idx="2">
+            <a:schemeClr val="accent1"/>
+          </a:effectRef>
+          <a:fontRef idx="minor">
+            <a:schemeClr val="lt1"/>
+          </a:fontRef>
+        </p:style>
+        <p:txBody>
+          <a:bodyPr rtlCol="0" anchor="ctr"/>
+          <a:lstStyle/>
+          <a:p>
+            <a:pPr algn="ctr"/>
+          </a:p>
+        </p:txBody>
+      </p:sp>
+      <p:sp>
+        <p:nvSpPr>
+          <p:cNvPr id="20" name="TextBox 19"/>
+          <p:cNvSpPr txBox="1"/>
+          <p:nvPr/>
+        </p:nvSpPr>
+        <p:spPr>
+          <a:xfrm>
+            <a:off x="3391200" y="2829599"/>
+            <a:ext cx="2030400" cy="162000"/>
+          </a:xfrm>
+          <a:prstGeom prst="rect">
+            <a:avLst/>
+          </a:prstGeom>
+          <a:noFill/>
+        </p:spPr>
+        <p:txBody>
+          <a:bodyPr wrap="square">
+            <a:spAutoFit/>
+          </a:bodyPr>
+          <a:lstStyle/>
+          <a:p>
+            <a:pPr algn="l">
+              <a:defRPr sz="900" b="0">
+                <a:solidFill>
+                  <a:srgbClr val="FFFFFF"/>
+                </a:solidFill>
+              </a:defRPr>
+            </a:pPr>
+            <a:r>
+              <a:t>AI绘画/视频生成全流程</a:t>
+            </a:r>
+          </a:p>
+        </p:txBody>
+      </p:sp>
+      <p:sp>
+        <p:nvSpPr>
+          <p:cNvPr id="21" name="Rectangle 20"/>
+          <p:cNvSpPr/>
+          <p:nvPr/>
+        </p:nvSpPr>
+        <p:spPr>
+          <a:xfrm>
+            <a:off x="1332000" y="3077998"/>
+            <a:ext cx="1497600" cy="180000"/>
+          </a:xfrm>
+          <a:prstGeom prst="rect">
+            <a:avLst/>
+          </a:prstGeom>
+          <a:solidFill>
+            <a:srgbClr val="1A1A2E"/>
+          </a:solidFill>
+          <a:ln>
+            <a:noFill/>
+          </a:ln>
+        </p:spPr>
+        <p:style>
+          <a:lnRef idx="1">
+            <a:schemeClr val="accent1"/>
+          </a:lnRef>
+          <a:fillRef idx="3">
+            <a:schemeClr val="accent1"/>
+          </a:fillRef>
+          <a:effectRef idx="2">
+            <a:schemeClr val="accent1"/>
+          </a:effectRef>
+          <a:fontRef idx="minor">
+            <a:schemeClr val="lt1"/>
+          </a:fontRef>
+        </p:style>
+        <p:txBody>
+          <a:bodyPr rtlCol="0" anchor="ctr"/>
+          <a:lstStyle/>
+          <a:p>
+            <a:pPr algn="ctr"/>
+          </a:p>
+        </p:txBody>
+      </p:sp>
+      <p:sp>
+        <p:nvSpPr>
+          <p:cNvPr id="22" name="TextBox 21"/>
+          <p:cNvSpPr txBox="1"/>
+          <p:nvPr/>
+        </p:nvSpPr>
+        <p:spPr>
+          <a:xfrm>
+            <a:off x="1368000" y="3081598"/>
+            <a:ext cx="1425600" cy="162000"/>
+          </a:xfrm>
+          <a:prstGeom prst="rect">
+            <a:avLst/>
+          </a:prstGeom>
+          <a:noFill/>
+        </p:spPr>
+        <p:txBody>
+          <a:bodyPr wrap="square">
+            <a:spAutoFit/>
+          </a:bodyPr>
+          <a:lstStyle/>
+          <a:p>
+            <a:pPr algn="l">
+              <a:defRPr sz="900" b="0">
+                <a:solidFill>
+                  <a:srgbClr val="FFFFFF"/>
+                </a:solidFill>
+              </a:defRPr>
+            </a:pPr>
+            <a:r>
+              <a:t>AIGC内容创作</a:t>
+            </a:r>
+          </a:p>
+        </p:txBody>
+      </p:sp>
+      <p:sp>
+        <p:nvSpPr>
+          <p:cNvPr id="23" name="TextBox 22"/>
+          <p:cNvSpPr txBox="1"/>
+          <p:nvPr/>
+        </p:nvSpPr>
+        <p:spPr>
+          <a:xfrm>
+            <a:off x="540000" y="3383998"/>
+            <a:ext cx="648000" cy="180000"/>
+          </a:xfrm>
+          <a:prstGeom prst="rect">
+            <a:avLst/>
+          </a:prstGeom>
+          <a:noFill/>
+        </p:spPr>
+        <p:txBody>
+          <a:bodyPr wrap="square">
+            <a:spAutoFit/>
+          </a:bodyPr>
+          <a:lstStyle/>
+          <a:p>
+            <a:pPr algn="l">
+              <a:defRPr sz="1100" b="1">
+                <a:solidFill>
+                  <a:srgbClr val="1A1A1A"/>
+                </a:solidFill>
+              </a:defRPr>
+            </a:pPr>
+            <a:r>
+              <a:t>熟练</a:t>
+            </a:r>
+          </a:p>
+        </p:txBody>
+      </p:sp>
+      <p:sp>
+        <p:nvSpPr>
+          <p:cNvPr id="24" name="Rectangle 23"/>
+          <p:cNvSpPr/>
+          <p:nvPr/>
+        </p:nvSpPr>
+        <p:spPr>
+          <a:xfrm>
+            <a:off x="1332000" y="3653997"/>
+            <a:ext cx="6184800" cy="180000"/>
+          </a:xfrm>
+          <a:prstGeom prst="rect">
+            <a:avLst/>
+          </a:prstGeom>
+          <a:solidFill>
+            <a:srgbClr val="1A1A2E"/>
+          </a:solidFill>
+          <a:ln>
+            <a:noFill/>
+          </a:ln>
+        </p:spPr>
+        <p:style>
+          <a:lnRef idx="1">
+            <a:schemeClr val="accent1"/>
+          </a:lnRef>
+          <a:fillRef idx="3">
+            <a:schemeClr val="accent1"/>
+          </a:fillRef>
+          <a:effectRef idx="2">
+            <a:schemeClr val="accent1"/>
+          </a:effectRef>
+          <a:fontRef idx="minor">
+            <a:schemeClr val="lt1"/>
+          </a:fontRef>
+        </p:style>
+        <p:txBody>
+          <a:bodyPr rtlCol="0" anchor="ctr"/>
+          <a:lstStyle/>
+          <a:p>
+            <a:pPr algn="ctr"/>
+          </a:p>
+        </p:txBody>
+      </p:sp>
+      <p:sp>
+        <p:nvSpPr>
+          <p:cNvPr id="25" name="TextBox 24"/>
+          <p:cNvSpPr txBox="1"/>
+          <p:nvPr/>
+        </p:nvSpPr>
+        <p:spPr>
+          <a:xfrm>
+            <a:off x="1368000" y="3657597"/>
+            <a:ext cx="6112800" cy="162000"/>
+          </a:xfrm>
+          <a:prstGeom prst="rect">
+            <a:avLst/>
+          </a:prstGeom>
+          <a:noFill/>
+        </p:spPr>
+        <p:txBody>
+          <a:bodyPr wrap="square">
+            <a:spAutoFit/>
+          </a:bodyPr>
+          <a:lstStyle/>
+          <a:p>
+            <a:pPr algn="l">
+              <a:defRPr sz="900" b="0">
+                <a:solidFill>
+                  <a:srgbClr val="FFFFFF"/>
+                </a:solidFill>
+              </a:defRPr>
+            </a:pPr>
+            <a:r>
+              <a:t>AI Agent开发（Claude Code/Codex/Open Claw）</a:t>
+            </a:r>
+          </a:p>
+        </p:txBody>
+      </p:sp>
+      <p:sp>
+        <p:nvSpPr>
+          <p:cNvPr id="26" name="Rectangle 25"/>
+          <p:cNvSpPr/>
+          <p:nvPr/>
+        </p:nvSpPr>
+        <p:spPr>
+          <a:xfrm>
+            <a:off x="1332000" y="3905996"/>
+            <a:ext cx="2102400" cy="180000"/>
+          </a:xfrm>
+          <a:prstGeom prst="rect">
+            <a:avLst/>
+          </a:prstGeom>
+          <a:solidFill>
+            <a:srgbClr val="1A1A2E"/>
+          </a:solidFill>
+          <a:ln>
+            <a:noFill/>
+          </a:ln>
+        </p:spPr>
+        <p:style>
+          <a:lnRef idx="1">
+            <a:schemeClr val="accent1"/>
+          </a:lnRef>
+          <a:fillRef idx="3">
+            <a:schemeClr val="accent1"/>
+          </a:fillRef>
+          <a:effectRef idx="2">
+            <a:schemeClr val="accent1"/>
+          </a:effectRef>
+          <a:fontRef idx="minor">
+            <a:schemeClr val="lt1"/>
+          </a:fontRef>
+        </p:style>
+        <p:txBody>
+          <a:bodyPr rtlCol="0" anchor="ctr"/>
+          <a:lstStyle/>
+          <a:p>
+            <a:pPr algn="ctr"/>
+          </a:p>
+        </p:txBody>
+      </p:sp>
+      <p:sp>
+        <p:nvSpPr>
+          <p:cNvPr id="27" name="TextBox 26"/>
+          <p:cNvSpPr txBox="1"/>
+          <p:nvPr/>
+        </p:nvSpPr>
+        <p:spPr>
+          <a:xfrm>
+            <a:off x="1368000" y="3909596"/>
+            <a:ext cx="2030400" cy="162000"/>
+          </a:xfrm>
+          <a:prstGeom prst="rect">
+            <a:avLst/>
+          </a:prstGeom>
+          <a:noFill/>
+        </p:spPr>
+        <p:txBody>
+          <a:bodyPr wrap="square">
+            <a:spAutoFit/>
+          </a:bodyPr>
+          <a:lstStyle/>
+          <a:p>
+            <a:pPr algn="l">
+              <a:defRPr sz="900" b="0">
+                <a:solidFill>
+                  <a:srgbClr val="FFFFFF"/>
+                </a:solidFill>
+              </a:defRPr>
+            </a:pPr>
+            <a:r>
+              <a:t>多Agent协作系统设计</a:t>
+            </a:r>
+          </a:p>
+        </p:txBody>
+      </p:sp>
+      <p:sp>
+        <p:nvSpPr>
+          <p:cNvPr id="28" name="Rectangle 27"/>
+          <p:cNvSpPr/>
+          <p:nvPr/>
+        </p:nvSpPr>
+        <p:spPr>
+          <a:xfrm>
+            <a:off x="3506400" y="3905996"/>
+            <a:ext cx="3463200" cy="180000"/>
+          </a:xfrm>
+          <a:prstGeom prst="rect">
+            <a:avLst/>
+          </a:prstGeom>
+          <a:solidFill>
+            <a:srgbClr val="1A1A2E"/>
+          </a:solidFill>
+          <a:ln>
+            <a:noFill/>
+          </a:ln>
+        </p:spPr>
+        <p:style>
+          <a:lnRef idx="1">
+            <a:schemeClr val="accent1"/>
+          </a:lnRef>
+          <a:fillRef idx="3">
+            <a:schemeClr val="accent1"/>
+          </a:fillRef>
+          <a:effectRef idx="2">
+            <a:schemeClr val="accent1"/>
+          </a:effectRef>
+          <a:fontRef idx="minor">
+            <a:schemeClr val="lt1"/>
+          </a:fontRef>
+        </p:style>
+        <p:txBody>
+          <a:bodyPr rtlCol="0" anchor="ctr"/>
+          <a:lstStyle/>
+          <a:p>
+            <a:pPr algn="ctr"/>
+          </a:p>
+        </p:txBody>
+      </p:sp>
+      <p:sp>
+        <p:nvSpPr>
+          <p:cNvPr id="29" name="TextBox 28"/>
+          <p:cNvSpPr txBox="1"/>
+          <p:nvPr/>
+        </p:nvSpPr>
+        <p:spPr>
+          <a:xfrm>
+            <a:off x="3542400" y="3909596"/>
+            <a:ext cx="3391200" cy="162000"/>
+          </a:xfrm>
+          <a:prstGeom prst="rect">
+            <a:avLst/>
+          </a:prstGeom>
+          <a:noFill/>
+        </p:spPr>
+        <p:txBody>
+          <a:bodyPr wrap="square">
+            <a:spAutoFit/>
+          </a:bodyPr>
+          <a:lstStyle/>
+          <a:p>
+            <a:pPr algn="l">
+              <a:defRPr sz="900" b="0">
+                <a:solidFill>
+                  <a:srgbClr val="FFFFFF"/>
+                </a:solidFill>
+              </a:defRPr>
+            </a:pPr>
+            <a:r>
+              <a:t>API集成（飞书/B站/DeepSeek）</a:t>
+            </a:r>
+          </a:p>
+        </p:txBody>
+      </p:sp>
+      <p:sp>
+        <p:nvSpPr>
+          <p:cNvPr id="30" name="Rectangle 29"/>
+          <p:cNvSpPr/>
+          <p:nvPr/>
+        </p:nvSpPr>
+        <p:spPr>
+          <a:xfrm>
+            <a:off x="1332000" y="4157995"/>
+            <a:ext cx="2858400" cy="180000"/>
+          </a:xfrm>
+          <a:prstGeom prst="rect">
+            <a:avLst/>
+          </a:prstGeom>
+          <a:solidFill>
+            <a:srgbClr val="1A1A2E"/>
+          </a:solidFill>
+          <a:ln>
+            <a:noFill/>
+          </a:ln>
+        </p:spPr>
+        <p:style>
+          <a:lnRef idx="1">
+            <a:schemeClr val="accent1"/>
+          </a:lnRef>
+          <a:fillRef idx="3">
+            <a:schemeClr val="accent1"/>
+          </a:fillRef>
+          <a:effectRef idx="2">
+            <a:schemeClr val="accent1"/>
+          </a:effectRef>
+          <a:fontRef idx="minor">
+            <a:schemeClr val="lt1"/>
+          </a:fontRef>
+        </p:style>
+        <p:txBody>
+          <a:bodyPr rtlCol="0" anchor="ctr"/>
+          <a:lstStyle/>
+          <a:p>
+            <a:pPr algn="ctr"/>
+          </a:p>
+        </p:txBody>
+      </p:sp>
+      <p:sp>
+        <p:nvSpPr>
+          <p:cNvPr id="31" name="TextBox 30"/>
+          <p:cNvSpPr txBox="1"/>
+          <p:nvPr/>
+        </p:nvSpPr>
+        <p:spPr>
+          <a:xfrm>
+            <a:off x="1368000" y="4161595"/>
+            <a:ext cx="2786400" cy="162000"/>
+          </a:xfrm>
+          <a:prstGeom prst="rect">
+            <a:avLst/>
+          </a:prstGeom>
+          <a:noFill/>
+        </p:spPr>
+        <p:txBody>
+          <a:bodyPr wrap="square">
+            <a:spAutoFit/>
+          </a:bodyPr>
+          <a:lstStyle/>
+          <a:p>
+            <a:pPr algn="l">
+              <a:defRPr sz="900" b="0">
+                <a:solidFill>
+                  <a:srgbClr val="FFFFFF"/>
+                </a:solidFill>
+              </a:defRPr>
+            </a:pPr>
+            <a:r>
+              <a:t>Photoshop/剪映/后期处理</a:t>
+            </a:r>
+          </a:p>
+        </p:txBody>
+      </p:sp>
+      <p:sp>
+        <p:nvSpPr>
+          <p:cNvPr id="32" name="Rectangle 31"/>
+          <p:cNvSpPr/>
+          <p:nvPr/>
+        </p:nvSpPr>
+        <p:spPr>
+          <a:xfrm>
+            <a:off x="540000" y="4571995"/>
+            <a:ext cx="54000" cy="251999"/>
+          </a:xfrm>
+          <a:prstGeom prst="rect">
+            <a:avLst/>
+          </a:prstGeom>
+          <a:solidFill>
+            <a:srgbClr val="5A9A5A"/>
+          </a:solidFill>
+          <a:ln>
+            <a:noFill/>
+          </a:ln>
+        </p:spPr>
+        <p:style>
+          <a:lnRef idx="1">
+            <a:schemeClr val="accent1"/>
+          </a:lnRef>
+          <a:fillRef idx="3">
+            <a:schemeClr val="accent1"/>
+          </a:fillRef>
+          <a:effectRef idx="2">
+            <a:schemeClr val="accent1"/>
+          </a:effectRef>
+          <a:fontRef idx="minor">
+            <a:schemeClr val="lt1"/>
+          </a:fontRef>
+        </p:style>
+        <p:txBody>
+          <a:bodyPr rtlCol="0" anchor="ctr"/>
+          <a:lstStyle/>
+          <a:p>
+            <a:pPr algn="ctr"/>
+          </a:p>
+        </p:txBody>
+      </p:sp>
+      <p:sp>
+        <p:nvSpPr>
+          <p:cNvPr id="33" name="TextBox 32"/>
+          <p:cNvSpPr txBox="1"/>
+          <p:nvPr/>
+        </p:nvSpPr>
+        <p:spPr>
+          <a:xfrm>
+            <a:off x="684000" y="4589995"/>
+            <a:ext cx="6480000" cy="216000"/>
+          </a:xfrm>
+          <a:prstGeom prst="rect">
+            <a:avLst/>
+          </a:prstGeom>
+          <a:noFill/>
+        </p:spPr>
+        <p:txBody>
+          <a:bodyPr wrap="square">
+            <a:spAutoFit/>
+          </a:bodyPr>
+          <a:lstStyle/>
+          <a:p>
+            <a:pPr algn="l">
+              <a:defRPr sz="1500" b="1">
+                <a:solidFill>
+                  <a:srgbClr val="1A1A1A"/>
+                </a:solidFill>
+              </a:defRPr>
+            </a:pPr>
+            <a:r>
+              <a:t>工作经历</a:t>
+            </a:r>
+          </a:p>
+        </p:txBody>
+      </p:sp>
+      <p:sp>
+        <p:nvSpPr>
+          <p:cNvPr id="34" name="TextBox 33"/>
+          <p:cNvSpPr txBox="1"/>
+          <p:nvPr/>
+        </p:nvSpPr>
+        <p:spPr>
+          <a:xfrm>
+            <a:off x="540000" y="4895995"/>
+            <a:ext cx="6480000" cy="180000"/>
+          </a:xfrm>
+          <a:prstGeom prst="rect">
+            <a:avLst/>
+          </a:prstGeom>
+          <a:noFill/>
+        </p:spPr>
+        <p:txBody>
+          <a:bodyPr wrap="square">
+            <a:spAutoFit/>
+          </a:bodyPr>
+          <a:lstStyle/>
+          <a:p>
+            <a:pPr algn="l">
+              <a:defRPr sz="1300" b="1">
+                <a:solidFill>
+                  <a:srgbClr val="1A1A1A"/>
+                </a:solidFill>
+              </a:defRPr>
+            </a:pPr>
+            <a:r>
+              <a:t>AI训练负责人  |  草图里（广州）科技有限公司</a:t>
+            </a:r>
+          </a:p>
+        </p:txBody>
+      </p:sp>
+      <p:sp>
+        <p:nvSpPr>
+          <p:cNvPr id="35" name="TextBox 34"/>
+          <p:cNvSpPr txBox="1"/>
+          <p:nvPr/>
+        </p:nvSpPr>
+        <p:spPr>
+          <a:xfrm>
+            <a:off x="540000" y="5075995"/>
+            <a:ext cx="6480000" cy="144000"/>
+          </a:xfrm>
+          <a:prstGeom prst="rect">
+            <a:avLst/>
+          </a:prstGeom>
+          <a:noFill/>
+        </p:spPr>
+        <p:txBody>
+          <a:bodyPr wrap="square">
+            <a:spAutoFit/>
+          </a:bodyPr>
+          <a:lstStyle/>
+          <a:p>
+            <a:pPr algn="l">
+              <a:defRPr sz="1000" b="0">
+                <a:solidFill>
+                  <a:srgbClr val="5A9A5A"/>
+                </a:solidFill>
+              </a:defRPr>
+            </a:pPr>
+            <a:r>
+              <a:t>2023.12-2026.01</a:t>
+            </a:r>
+          </a:p>
+        </p:txBody>
+      </p:sp>
+      <p:sp>
+        <p:nvSpPr>
+          <p:cNvPr id="36" name="TextBox 35"/>
+          <p:cNvSpPr txBox="1"/>
+          <p:nvPr/>
+        </p:nvSpPr>
+        <p:spPr>
+          <a:xfrm>
+            <a:off x="648000" y="5255995"/>
+            <a:ext cx="6372000" cy="2088000"/>
+          </a:xfrm>
+          <a:prstGeom prst="rect">
+            <a:avLst/>
+          </a:prstGeom>
+          <a:noFill/>
+        </p:spPr>
+        <p:txBody>
+          <a:bodyPr wrap="square">
+            <a:spAutoFit/>
+          </a:bodyPr>
+          <a:lstStyle/>
+          <a:p>
+            <a:pPr>
+              <a:spcAft>
+                <a:spcPts val="300"/>
+              </a:spcAft>
+              <a:defRPr sz="1000">
+                <a:solidFill>
+                  <a:srgbClr val="1A1A1A"/>
+                </a:solidFill>
+              </a:defRPr>
+            </a:pPr>
+            <a:r>
+              <a:t>• 管理AI训练组与研发组（10+人），建立招聘-培训-考核全流程管理体系，团队交付效率提升40%</a:t>
+            </a:r>
+          </a:p>
+          <a:p>
+            <a:pPr>
+              <a:spcAft>
+                <a:spcPts val="300"/>
+              </a:spcAft>
+              <a:defRPr sz="1000">
+                <a:solidFill>
+                  <a:srgbClr val="1A1A1A"/>
+                </a:solidFill>
+              </a:defRPr>
+            </a:pPr>
+            <a:r>
+              <a:t>• 主导搭建ComfyUI标准化工作流库，整理70+工作流文档并推动产品化，工作流复用率从15%提升至75%</a:t>
+            </a:r>
+          </a:p>
+          <a:p>
+            <a:pPr>
+              <a:spcAft>
+                <a:spcPts val="300"/>
+              </a:spcAft>
+              <a:defRPr sz="1000">
+                <a:solidFill>
+                  <a:srgbClr val="1A1A1A"/>
+                </a:solidFill>
+              </a:defRPr>
+            </a:pPr>
+            <a:r>
+              <a:t>• 建立研发工作评估审核机制，将模型交付质量评分从平均6.8分提升至8.5分（10分制）</a:t>
+            </a:r>
+          </a:p>
+          <a:p>
+            <a:pPr>
+              <a:spcAft>
+                <a:spcPts val="300"/>
+              </a:spcAft>
+              <a:defRPr sz="1000">
+                <a:solidFill>
+                  <a:srgbClr val="1A1A1A"/>
+                </a:solidFill>
+              </a:defRPr>
+            </a:pPr>
+            <a:r>
+              <a:t>• 持续跟踪Flux、Nano Banana等前沿AI工具，输出12+份技术评估报告，推动3项关键技术选型决策</a:t>
+            </a:r>
+          </a:p>
+          <a:p>
+            <a:pPr>
+              <a:spcAft>
+                <a:spcPts val="300"/>
+              </a:spcAft>
+              <a:defRPr sz="1000">
+                <a:solidFill>
+                  <a:srgbClr val="1A1A1A"/>
+                </a:solidFill>
+              </a:defRPr>
+            </a:pPr>
+            <a:r>
+              <a:t>• 实现从单张参考图到批量出图的完整自动化管线，将客户项目出图周期缩短60%</a:t>
+            </a:r>
+          </a:p>
+        </p:txBody>
+      </p:sp>
+      <p:sp>
+        <p:nvSpPr>
+          <p:cNvPr id="37" name="TextBox 36"/>
+          <p:cNvSpPr txBox="1"/>
+          <p:nvPr/>
+        </p:nvSpPr>
+        <p:spPr>
+          <a:xfrm>
+            <a:off x="540000" y="7343995"/>
+            <a:ext cx="6480000" cy="180000"/>
+          </a:xfrm>
+          <a:prstGeom prst="rect">
+            <a:avLst/>
+          </a:prstGeom>
+          <a:noFill/>
+        </p:spPr>
+        <p:txBody>
+          <a:bodyPr wrap="square">
+            <a:spAutoFit/>
+          </a:bodyPr>
+          <a:lstStyle/>
+          <a:p>
+            <a:pPr algn="l">
+              <a:defRPr sz="1300" b="1">
+                <a:solidFill>
+                  <a:srgbClr val="1A1A1A"/>
+                </a:solidFill>
+              </a:defRPr>
+            </a:pPr>
+            <a:r>
+              <a:t>AI训练师  |  深圳安达曼科技有限公司</a:t>
+            </a:r>
+          </a:p>
+        </p:txBody>
+      </p:sp>
+      <p:sp>
+        <p:nvSpPr>
+          <p:cNvPr id="38" name="TextBox 37"/>
+          <p:cNvSpPr txBox="1"/>
+          <p:nvPr/>
+        </p:nvSpPr>
+        <p:spPr>
+          <a:xfrm>
+            <a:off x="540000" y="7523995"/>
+            <a:ext cx="6480000" cy="144000"/>
+          </a:xfrm>
+          <a:prstGeom prst="rect">
+            <a:avLst/>
+          </a:prstGeom>
+          <a:noFill/>
+        </p:spPr>
+        <p:txBody>
+          <a:bodyPr wrap="square">
+            <a:spAutoFit/>
+          </a:bodyPr>
+          <a:lstStyle/>
+          <a:p>
+            <a:pPr algn="l">
+              <a:defRPr sz="1000" b="0">
+                <a:solidFill>
+                  <a:srgbClr val="5A9A5A"/>
+                </a:solidFill>
+              </a:defRPr>
+            </a:pPr>
+            <a:r>
+              <a:t>2026.03-2026.06</a:t>
+            </a:r>
+          </a:p>
+        </p:txBody>
+      </p:sp>
+      <p:sp>
+        <p:nvSpPr>
+          <p:cNvPr id="39" name="TextBox 38"/>
+          <p:cNvSpPr txBox="1"/>
+          <p:nvPr/>
+        </p:nvSpPr>
+        <p:spPr>
+          <a:xfrm>
+            <a:off x="648000" y="7703995"/>
+            <a:ext cx="6372000" cy="1512000"/>
+          </a:xfrm>
+          <a:prstGeom prst="rect">
+            <a:avLst/>
+          </a:prstGeom>
+          <a:noFill/>
+        </p:spPr>
+        <p:txBody>
+          <a:bodyPr wrap="square">
+            <a:spAutoFit/>
+          </a:bodyPr>
+          <a:lstStyle/>
+          <a:p>
+            <a:pPr>
+              <a:spcAft>
+                <a:spcPts val="300"/>
+              </a:spcAft>
+              <a:defRPr sz="1000">
+                <a:solidFill>
+                  <a:srgbClr val="1A1A1A"/>
+                </a:solidFill>
+              </a:defRPr>
+            </a:pPr>
+            <a:r>
+              <a:t>• 负责AI模型训练及ComfyUI工作流搭建，快速复用草图里时期积累的标准化流程</a:t>
+            </a:r>
+          </a:p>
+          <a:p>
+            <a:pPr>
+              <a:spcAft>
+                <a:spcPts val="300"/>
+              </a:spcAft>
+              <a:defRPr sz="1000">
+                <a:solidFill>
+                  <a:srgbClr val="1A1A1A"/>
+                </a:solidFill>
+              </a:defRPr>
+            </a:pPr>
+            <a:r>
+              <a:t>• 探索实践AI Agent自动化工具链（Claude Code/Codex/Open Claw），探索AI编程与内容创作融合场景</a:t>
+            </a:r>
+          </a:p>
+          <a:p>
+            <a:pPr>
+              <a:spcAft>
+                <a:spcPts val="300"/>
+              </a:spcAft>
+              <a:defRPr sz="1000">
+                <a:solidFill>
+                  <a:srgbClr val="1A1A1A"/>
+                </a:solidFill>
+              </a:defRPr>
+            </a:pPr>
+            <a:r>
+              <a:t>• 岗位发展不符合未来趋势，离职后聚焦AI科技自媒体方向，将技术积累转化为内容影响力</a:t>
             </a:r>
           </a:p>
         </p:txBody>
@@ -3315,20 +4666,158 @@
       <p:grpSpPr/>
       <p:sp>
         <p:nvSpPr>
-          <p:cNvPr id="2" name="Rectangle 1"/>
+          <p:cNvPr id="2" name="TextBox 1"/>
+          <p:cNvSpPr txBox="1"/>
+          <p:nvPr/>
+        </p:nvSpPr>
+        <p:spPr>
+          <a:xfrm>
+            <a:off x="540000" y="0"/>
+            <a:ext cx="6480000" cy="180000"/>
+          </a:xfrm>
+          <a:prstGeom prst="rect">
+            <a:avLst/>
+          </a:prstGeom>
+          <a:noFill/>
+        </p:spPr>
+        <p:txBody>
+          <a:bodyPr wrap="square">
+            <a:spAutoFit/>
+          </a:bodyPr>
+          <a:lstStyle/>
+          <a:p>
+            <a:pPr algn="l">
+              <a:defRPr sz="1300" b="1">
+                <a:solidFill>
+                  <a:srgbClr val="1A1A1A"/>
+                </a:solidFill>
+              </a:defRPr>
+            </a:pPr>
+            <a:r>
+              <a:t>AIGC技术应用与行业实践  |  </a:t>
+            </a:r>
+          </a:p>
+        </p:txBody>
+      </p:sp>
+      <p:sp>
+        <p:nvSpPr>
+          <p:cNvPr id="3" name="TextBox 2"/>
+          <p:cNvSpPr txBox="1"/>
+          <p:nvPr/>
+        </p:nvSpPr>
+        <p:spPr>
+          <a:xfrm>
+            <a:off x="540000" y="180000"/>
+            <a:ext cx="6480000" cy="144000"/>
+          </a:xfrm>
+          <a:prstGeom prst="rect">
+            <a:avLst/>
+          </a:prstGeom>
+          <a:noFill/>
+        </p:spPr>
+        <p:txBody>
+          <a:bodyPr wrap="square">
+            <a:spAutoFit/>
+          </a:bodyPr>
+          <a:lstStyle/>
+          <a:p>
+            <a:pPr algn="l">
+              <a:defRPr sz="1000" b="0">
+                <a:solidFill>
+                  <a:srgbClr val="5A9A5A"/>
+                </a:solidFill>
+              </a:defRPr>
+            </a:pPr>
+            <a:r>
+              <a:t>2022.12-2023.12</a:t>
+            </a:r>
+          </a:p>
+        </p:txBody>
+      </p:sp>
+      <p:sp>
+        <p:nvSpPr>
+          <p:cNvPr id="4" name="TextBox 3"/>
+          <p:cNvSpPr txBox="1"/>
+          <p:nvPr/>
+        </p:nvSpPr>
+        <p:spPr>
+          <a:xfrm>
+            <a:off x="648000" y="360000"/>
+            <a:ext cx="6372000" cy="1512000"/>
+          </a:xfrm>
+          <a:prstGeom prst="rect">
+            <a:avLst/>
+          </a:prstGeom>
+          <a:noFill/>
+        </p:spPr>
+        <p:txBody>
+          <a:bodyPr wrap="square">
+            <a:spAutoFit/>
+          </a:bodyPr>
+          <a:lstStyle/>
+          <a:p>
+            <a:pPr>
+              <a:spcAft>
+                <a:spcPts val="300"/>
+              </a:spcAft>
+              <a:defRPr sz="1000">
+                <a:solidFill>
+                  <a:srgbClr val="1A1A1A"/>
+                </a:solidFill>
+              </a:defRPr>
+            </a:pPr>
+            <a:r>
+              <a:t>• 在B站持续输入AIGC前沿内容，累计发布50篇AI教程笔记，阅读量16万+</a:t>
+            </a:r>
+          </a:p>
+          <a:p>
+            <a:pPr>
+              <a:spcAft>
+                <a:spcPts val="300"/>
+              </a:spcAft>
+              <a:defRPr sz="1000">
+                <a:solidFill>
+                  <a:srgbClr val="1A1A1A"/>
+                </a:solidFill>
+              </a:defRPr>
+            </a:pPr>
+            <a:r>
+              <a:t>• 先后为2家企业搭建AIGC设计管线，将AI绘画工具引入实际业务流程，设计出图效率提升50%</a:t>
+            </a:r>
+          </a:p>
+          <a:p>
+            <a:pPr>
+              <a:spcAft>
+                <a:spcPts val="300"/>
+              </a:spcAft>
+              <a:defRPr sz="1000">
+                <a:solidFill>
+                  <a:srgbClr val="1A1A1A"/>
+                </a:solidFill>
+              </a:defRPr>
+            </a:pPr>
+            <a:r>
+              <a:t>• 独立完成从技术调研、方案设计到落地培训的全流程，为后续标准化工作流体系奠定核心基础</a:t>
+            </a:r>
+          </a:p>
+        </p:txBody>
+      </p:sp>
+      <p:sp>
+        <p:nvSpPr>
+          <p:cNvPr id="5" name="Rectangle 4"/>
           <p:cNvSpPr/>
           <p:nvPr/>
         </p:nvSpPr>
         <p:spPr>
           <a:xfrm>
-            <a:off x="0" y="0"/>
-            <a:ext cx="12191695" cy="914400"/>
+            <a:off x="540000" y="1872000"/>
+            <a:ext cx="54000" cy="251999"/>
           </a:xfrm>
           <a:prstGeom prst="rect">
             <a:avLst/>
           </a:prstGeom>
           <a:solidFill>
-            <a:srgbClr val="F0EFE8"/>
+            <a:srgbClr val="5A9A5A"/>
           </a:solidFill>
           <a:ln>
             <a:noFill/>
@@ -3349,32 +4838,23 @@
           </a:fontRef>
         </p:style>
         <p:txBody>
-          <a:bodyPr rtlCol="0" anchor="ctr" wrap="square" lIns="548640" tIns="137160"/>
-          <a:lstStyle/>
-          <a:p>
-            <a:pPr algn="l">
-              <a:defRPr sz="2800" b="1">
-                <a:solidFill>
-                  <a:srgbClr val="1A1A1A"/>
-                </a:solidFill>
-              </a:defRPr>
-            </a:pPr>
-            <a:r>
-              <a:t>核心技能</a:t>
-            </a:r>
-          </a:p>
-        </p:txBody>
-      </p:sp>
-      <p:sp>
-        <p:nvSpPr>
-          <p:cNvPr id="3" name="TextBox 2"/>
+          <a:bodyPr rtlCol="0" anchor="ctr"/>
+          <a:lstStyle/>
+          <a:p>
+            <a:pPr algn="ctr"/>
+          </a:p>
+        </p:txBody>
+      </p:sp>
+      <p:sp>
+        <p:nvSpPr>
+          <p:cNvPr id="6" name="TextBox 5"/>
           <p:cNvSpPr txBox="1"/>
           <p:nvPr/>
         </p:nvSpPr>
         <p:spPr>
           <a:xfrm>
-            <a:off x="548640" y="1188720"/>
-            <a:ext cx="2286000" cy="365760"/>
+            <a:off x="684000" y="1890000"/>
+            <a:ext cx="6480000" cy="216000"/>
           </a:xfrm>
           <a:prstGeom prst="rect">
             <a:avLst/>
@@ -3387,29 +4867,29 @@
           </a:bodyPr>
           <a:lstStyle/>
           <a:p>
-            <a:pPr>
-              <a:defRPr sz="1600" b="1">
+            <a:pPr algn="l">
+              <a:defRPr sz="1500" b="1">
                 <a:solidFill>
                   <a:srgbClr val="1A1A1A"/>
                 </a:solidFill>
               </a:defRPr>
             </a:pPr>
             <a:r>
-              <a:t>精通</a:t>
-            </a:r>
-          </a:p>
-        </p:txBody>
-      </p:sp>
-      <p:sp>
-        <p:nvSpPr>
-          <p:cNvPr id="4" name="TextBox 3"/>
+              <a:t>项目经验</a:t>
+            </a:r>
+          </a:p>
+        </p:txBody>
+      </p:sp>
+      <p:sp>
+        <p:nvSpPr>
+          <p:cNvPr id="7" name="TextBox 6"/>
           <p:cNvSpPr txBox="1"/>
           <p:nvPr/>
         </p:nvSpPr>
         <p:spPr>
           <a:xfrm>
-            <a:off x="2926080" y="1188720"/>
-            <a:ext cx="2103120" cy="320040"/>
+            <a:off x="540000" y="2196000"/>
+            <a:ext cx="6480000" cy="180000"/>
           </a:xfrm>
           <a:prstGeom prst="rect">
             <a:avLst/>
@@ -3422,29 +4902,29 @@
           </a:bodyPr>
           <a:lstStyle/>
           <a:p>
-            <a:pPr>
-              <a:defRPr sz="1200" b="0">
+            <a:pPr algn="l">
+              <a:defRPr sz="1300" b="1">
                 <a:solidFill>
                   <a:srgbClr val="1A1A1A"/>
                 </a:solidFill>
               </a:defRPr>
             </a:pPr>
             <a:r>
-              <a:t>Stable Diffusion</a:t>
-            </a:r>
-          </a:p>
-        </p:txBody>
-      </p:sp>
-      <p:sp>
-        <p:nvSpPr>
-          <p:cNvPr id="5" name="TextBox 4"/>
+              <a:t>novel-factory：AI长篇小说自动写作与发布系统  —  独立开发者</a:t>
+            </a:r>
+          </a:p>
+        </p:txBody>
+      </p:sp>
+      <p:sp>
+        <p:nvSpPr>
+          <p:cNvPr id="8" name="TextBox 7"/>
           <p:cNvSpPr txBox="1"/>
           <p:nvPr/>
         </p:nvSpPr>
         <p:spPr>
           <a:xfrm>
-            <a:off x="5212080" y="1188720"/>
-            <a:ext cx="2103120" cy="320040"/>
+            <a:off x="648000" y="2376000"/>
+            <a:ext cx="6372000" cy="1295999"/>
           </a:xfrm>
           <a:prstGeom prst="rect">
             <a:avLst/>
@@ -3458,28 +4938,61 @@
           <a:lstStyle/>
           <a:p>
             <a:pPr>
-              <a:defRPr sz="1200" b="0">
+              <a:spcAft>
+                <a:spcPts val="300"/>
+              </a:spcAft>
+              <a:defRPr sz="1000">
                 <a:solidFill>
                   <a:srgbClr val="1A1A1A"/>
                 </a:solidFill>
               </a:defRPr>
             </a:pPr>
             <a:r>
-              <a:t>ComfyUI工作流搭建</a:t>
-            </a:r>
-          </a:p>
-        </p:txBody>
-      </p:sp>
-      <p:sp>
-        <p:nvSpPr>
-          <p:cNvPr id="6" name="TextBox 5"/>
+              <a:t>• 设计AI作者/编辑/审校多Agent协作架构，实现从选题→写作→审校→发布的完整自动化链路</a:t>
+            </a:r>
+          </a:p>
+          <a:p>
+            <a:pPr>
+              <a:spcAft>
+                <a:spcPts val="300"/>
+              </a:spcAft>
+              <a:defRPr sz="1000">
+                <a:solidFill>
+                  <a:srgbClr val="1A1A1A"/>
+                </a:solidFill>
+              </a:defRPr>
+            </a:pPr>
+            <a:r>
+              <a:t>• 集成飞书文档API实现云端同步存储，支持定时发布调度，单次可生成10万字长篇小说</a:t>
+            </a:r>
+          </a:p>
+          <a:p>
+            <a:pPr>
+              <a:spcAft>
+                <a:spcPts val="300"/>
+              </a:spcAft>
+              <a:defRPr sz="1000">
+                <a:solidFill>
+                  <a:srgbClr val="1A1A1A"/>
+                </a:solidFill>
+              </a:defRPr>
+            </a:pPr>
+            <a:r>
+              <a:t>• 部署在Linux服务器（systemd守护进程），实现7×24小时无人值守运行</a:t>
+            </a:r>
+          </a:p>
+        </p:txBody>
+      </p:sp>
+      <p:sp>
+        <p:nvSpPr>
+          <p:cNvPr id="9" name="TextBox 8"/>
           <p:cNvSpPr txBox="1"/>
           <p:nvPr/>
         </p:nvSpPr>
         <p:spPr>
           <a:xfrm>
-            <a:off x="7498079" y="1188720"/>
-            <a:ext cx="2103120" cy="320040"/>
+            <a:off x="540000" y="3671999"/>
+            <a:ext cx="6480000" cy="180000"/>
           </a:xfrm>
           <a:prstGeom prst="rect">
             <a:avLst/>
@@ -3492,29 +5005,29 @@
           </a:bodyPr>
           <a:lstStyle/>
           <a:p>
-            <a:pPr>
-              <a:defRPr sz="1200" b="0">
+            <a:pPr algn="l">
+              <a:defRPr sz="1300" b="1">
                 <a:solidFill>
                   <a:srgbClr val="1A1A1A"/>
                 </a:solidFill>
               </a:defRPr>
             </a:pPr>
             <a:r>
-              <a:t>LoRA模型训练与调优</a:t>
-            </a:r>
-          </a:p>
-        </p:txBody>
-      </p:sp>
-      <p:sp>
-        <p:nvSpPr>
-          <p:cNvPr id="7" name="TextBox 6"/>
+              <a:t>bilibili-to-feishu-note-bot：B站视频→飞书AI笔记机器人  —  独立开发者</a:t>
+            </a:r>
+          </a:p>
+        </p:txBody>
+      </p:sp>
+      <p:sp>
+        <p:nvSpPr>
+          <p:cNvPr id="10" name="TextBox 9"/>
           <p:cNvSpPr txBox="1"/>
           <p:nvPr/>
         </p:nvSpPr>
         <p:spPr>
           <a:xfrm>
-            <a:off x="9784080" y="1188720"/>
-            <a:ext cx="2103120" cy="320040"/>
+            <a:off x="648000" y="3851999"/>
+            <a:ext cx="6372000" cy="1295999"/>
           </a:xfrm>
           <a:prstGeom prst="rect">
             <a:avLst/>
@@ -3528,28 +5041,61 @@
           <a:lstStyle/>
           <a:p>
             <a:pPr>
-              <a:defRPr sz="1200" b="0">
+              <a:spcAft>
+                <a:spcPts val="300"/>
+              </a:spcAft>
+              <a:defRPr sz="1000">
                 <a:solidFill>
                   <a:srgbClr val="1A1A1A"/>
                 </a:solidFill>
               </a:defRPr>
             </a:pPr>
             <a:r>
-              <a:t>AI绘画/视频生成全流程</a:t>
-            </a:r>
-          </a:p>
-        </p:txBody>
-      </p:sp>
-      <p:sp>
-        <p:nvSpPr>
-          <p:cNvPr id="8" name="TextBox 7"/>
+              <a:t>• 实现B站视频自动下载→音频提取→Whisper语音转录→DeepSeek结构化笔记生成的全流程自动化</a:t>
+            </a:r>
+          </a:p>
+          <a:p>
+            <a:pPr>
+              <a:spcAft>
+                <a:spcPts val="300"/>
+              </a:spcAft>
+              <a:defRPr sz="1000">
+                <a:solidFill>
+                  <a:srgbClr val="1A1A1A"/>
+                </a:solidFill>
+              </a:defRPr>
+            </a:pPr>
+            <a:r>
+              <a:t>• 自动生成带时间戳、关键观点、思维导图的结构化飞书文档，笔记生成准确率达90%+</a:t>
+            </a:r>
+          </a:p>
+          <a:p>
+            <a:pPr>
+              <a:spcAft>
+                <a:spcPts val="300"/>
+              </a:spcAft>
+              <a:defRPr sz="1000">
+                <a:solidFill>
+                  <a:srgbClr val="1A1A1A"/>
+                </a:solidFill>
+              </a:defRPr>
+            </a:pPr>
+            <a:r>
+              <a:t>• 支持定时监控UP主更新，自动触发笔记生成流程，累计处理视频500+个</a:t>
+            </a:r>
+          </a:p>
+        </p:txBody>
+      </p:sp>
+      <p:sp>
+        <p:nvSpPr>
+          <p:cNvPr id="11" name="TextBox 10"/>
           <p:cNvSpPr txBox="1"/>
           <p:nvPr/>
         </p:nvSpPr>
         <p:spPr>
           <a:xfrm>
-            <a:off x="2926080" y="1508760"/>
-            <a:ext cx="2103120" cy="320040"/>
+            <a:off x="540000" y="5147998"/>
+            <a:ext cx="6480000" cy="180000"/>
           </a:xfrm>
           <a:prstGeom prst="rect">
             <a:avLst/>
@@ -3562,29 +5108,29 @@
           </a:bodyPr>
           <a:lstStyle/>
           <a:p>
-            <a:pPr>
-              <a:defRPr sz="1200" b="0">
+            <a:pPr algn="l">
+              <a:defRPr sz="1300" b="1">
                 <a:solidFill>
                   <a:srgbClr val="1A1A1A"/>
                 </a:solidFill>
               </a:defRPr>
             </a:pPr>
             <a:r>
-              <a:t>AIGC内容创作</a:t>
-            </a:r>
-          </a:p>
-        </p:txBody>
-      </p:sp>
-      <p:sp>
-        <p:nvSpPr>
-          <p:cNvPr id="9" name="TextBox 8"/>
+              <a:t>AI模型发布与社区影响力建设  —  创作者/模型训练师</a:t>
+            </a:r>
+          </a:p>
+        </p:txBody>
+      </p:sp>
+      <p:sp>
+        <p:nvSpPr>
+          <p:cNvPr id="12" name="TextBox 11"/>
           <p:cNvSpPr txBox="1"/>
           <p:nvPr/>
         </p:nvSpPr>
         <p:spPr>
           <a:xfrm>
-            <a:off x="548640" y="2286000"/>
-            <a:ext cx="2286000" cy="365760"/>
+            <a:off x="648000" y="5327998"/>
+            <a:ext cx="6372000" cy="1044000"/>
           </a:xfrm>
           <a:prstGeom prst="rect">
             <a:avLst/>
@@ -3598,200 +5144,52 @@
           <a:lstStyle/>
           <a:p>
             <a:pPr>
-              <a:defRPr sz="1600" b="1">
+              <a:spcAft>
+                <a:spcPts val="300"/>
+              </a:spcAft>
+              <a:defRPr sz="1000">
                 <a:solidFill>
                   <a:srgbClr val="1A1A1A"/>
                 </a:solidFill>
               </a:defRPr>
             </a:pPr>
             <a:r>
-              <a:t>熟练</a:t>
-            </a:r>
-          </a:p>
-        </p:txBody>
-      </p:sp>
-      <p:sp>
-        <p:nvSpPr>
-          <p:cNvPr id="10" name="TextBox 9"/>
-          <p:cNvSpPr txBox="1"/>
-          <p:nvPr/>
-        </p:nvSpPr>
-        <p:spPr>
-          <a:xfrm>
-            <a:off x="2926080" y="2286000"/>
-            <a:ext cx="2103120" cy="320040"/>
-          </a:xfrm>
-          <a:prstGeom prst="rect">
-            <a:avLst/>
-          </a:prstGeom>
-          <a:noFill/>
-        </p:spPr>
-        <p:txBody>
-          <a:bodyPr wrap="square">
-            <a:spAutoFit/>
-          </a:bodyPr>
-          <a:lstStyle/>
+              <a:t>• 在Liblib及小红书运营个人AI账号，专注景观/汽车/电商/游戏四大垂直行业LoRA模型</a:t>
+            </a:r>
+          </a:p>
           <a:p>
             <a:pPr>
-              <a:defRPr sz="1200" b="0">
+              <a:spcAft>
+                <a:spcPts val="300"/>
+              </a:spcAft>
+              <a:defRPr sz="1000">
                 <a:solidFill>
                   <a:srgbClr val="1A1A1A"/>
                 </a:solidFill>
               </a:defRPr>
             </a:pPr>
             <a:r>
-              <a:t>AI Agent开发（Claude Code/Codex/Open Claw）</a:t>
-            </a:r>
-          </a:p>
-        </p:txBody>
-      </p:sp>
-      <p:sp>
-        <p:nvSpPr>
-          <p:cNvPr id="11" name="TextBox 10"/>
-          <p:cNvSpPr txBox="1"/>
-          <p:nvPr/>
-        </p:nvSpPr>
-        <p:spPr>
-          <a:xfrm>
-            <a:off x="5212080" y="2286000"/>
-            <a:ext cx="2103120" cy="320040"/>
-          </a:xfrm>
-          <a:prstGeom prst="rect">
-            <a:avLst/>
-          </a:prstGeom>
-          <a:noFill/>
-        </p:spPr>
-        <p:txBody>
-          <a:bodyPr wrap="square">
-            <a:spAutoFit/>
-          </a:bodyPr>
-          <a:lstStyle/>
-          <a:p>
-            <a:pPr>
-              <a:defRPr sz="1200" b="0">
-                <a:solidFill>
-                  <a:srgbClr val="1A1A1A"/>
-                </a:solidFill>
-              </a:defRPr>
-            </a:pPr>
-            <a:r>
-              <a:t>多Agent协作系统设计</a:t>
-            </a:r>
-          </a:p>
-        </p:txBody>
-      </p:sp>
-      <p:sp>
-        <p:nvSpPr>
-          <p:cNvPr id="12" name="TextBox 11"/>
-          <p:cNvSpPr txBox="1"/>
-          <p:nvPr/>
-        </p:nvSpPr>
-        <p:spPr>
-          <a:xfrm>
-            <a:off x="7498079" y="2286000"/>
-            <a:ext cx="2103120" cy="320040"/>
-          </a:xfrm>
-          <a:prstGeom prst="rect">
-            <a:avLst/>
-          </a:prstGeom>
-          <a:noFill/>
-        </p:spPr>
-        <p:txBody>
-          <a:bodyPr wrap="square">
-            <a:spAutoFit/>
-          </a:bodyPr>
-          <a:lstStyle/>
-          <a:p>
-            <a:pPr>
-              <a:defRPr sz="1200" b="0">
-                <a:solidFill>
-                  <a:srgbClr val="1A1A1A"/>
-                </a:solidFill>
-              </a:defRPr>
-            </a:pPr>
-            <a:r>
-              <a:t>API集成（飞书/B站/DeepSeek）</a:t>
-            </a:r>
-          </a:p>
-        </p:txBody>
-      </p:sp>
-      <p:sp>
-        <p:nvSpPr>
-          <p:cNvPr id="13" name="TextBox 12"/>
-          <p:cNvSpPr txBox="1"/>
-          <p:nvPr/>
-        </p:nvSpPr>
-        <p:spPr>
-          <a:xfrm>
-            <a:off x="9784080" y="2286000"/>
-            <a:ext cx="2103120" cy="320040"/>
-          </a:xfrm>
-          <a:prstGeom prst="rect">
-            <a:avLst/>
-          </a:prstGeom>
-          <a:noFill/>
-        </p:spPr>
-        <p:txBody>
-          <a:bodyPr wrap="square">
-            <a:spAutoFit/>
-          </a:bodyPr>
-          <a:lstStyle/>
-          <a:p>
-            <a:pPr>
-              <a:defRPr sz="1200" b="0">
-                <a:solidFill>
-                  <a:srgbClr val="1A1A1A"/>
-                </a:solidFill>
-              </a:defRPr>
-            </a:pPr>
-            <a:r>
-              <a:t>Photoshop/剪映/后期处理</a:t>
-            </a:r>
-          </a:p>
-        </p:txBody>
-      </p:sp>
-    </p:spTree>
-  </p:cSld>
-  <p:clrMapOvr>
-    <a:masterClrMapping/>
-  </p:clrMapOvr>
-</p:sld>
-</file>
-
-<file path=ppt/slides/slide3.xml><?xml version="1.0" encoding="utf-8"?>
-<p:sld xmlns:a="http://schemas.openxmlformats.org/drawingml/2006/main" xmlns:p="http://schemas.openxmlformats.org/presentationml/2006/main" xmlns:r="http://schemas.openxmlformats.org/officeDocument/2006/relationships">
-  <p:cSld>
-    <p:bg>
-      <p:bgPr>
-        <a:solidFill>
-          <a:srgbClr val="FFFFFF"/>
-        </a:solidFill>
-        <a:effectLst/>
-      </p:bgPr>
-    </p:bg>
-    <p:spTree>
-      <p:nvGrpSpPr>
-        <p:cNvPr id="1" name=""/>
-        <p:cNvGrpSpPr/>
-        <p:nvPr/>
-      </p:nvGrpSpPr>
-      <p:grpSpPr/>
-      <p:sp>
-        <p:nvSpPr>
-          <p:cNvPr id="2" name="Rectangle 1"/>
+              <a:t>• 发布Lora模型、ComfyUI工作流、AI图片及视频作品50+个，模型总使用次数80K+，获赞1.7K+</a:t>
+            </a:r>
+          </a:p>
+        </p:txBody>
+      </p:sp>
+      <p:sp>
+        <p:nvSpPr>
+          <p:cNvPr id="13" name="Rectangle 12"/>
           <p:cNvSpPr/>
           <p:nvPr/>
         </p:nvSpPr>
         <p:spPr>
           <a:xfrm>
-            <a:off x="0" y="0"/>
-            <a:ext cx="12191695" cy="914400"/>
+            <a:off x="540000" y="6371998"/>
+            <a:ext cx="54000" cy="251999"/>
           </a:xfrm>
           <a:prstGeom prst="rect">
             <a:avLst/>
           </a:prstGeom>
           <a:solidFill>
-            <a:srgbClr val="F0EFE8"/>
+            <a:srgbClr val="5A9A5A"/>
           </a:solidFill>
           <a:ln>
             <a:noFill/>
@@ -3812,32 +5210,23 @@
           </a:fontRef>
         </p:style>
         <p:txBody>
-          <a:bodyPr rtlCol="0" anchor="ctr" wrap="square" lIns="548640" tIns="137160"/>
-          <a:lstStyle/>
-          <a:p>
-            <a:pPr algn="l">
-              <a:defRPr sz="2800" b="1">
-                <a:solidFill>
-                  <a:srgbClr val="1A1A1A"/>
-                </a:solidFill>
-              </a:defRPr>
-            </a:pPr>
-            <a:r>
-              <a:t>工作经历 1/3</a:t>
-            </a:r>
-          </a:p>
-        </p:txBody>
-      </p:sp>
-      <p:sp>
-        <p:nvSpPr>
-          <p:cNvPr id="3" name="TextBox 2"/>
+          <a:bodyPr rtlCol="0" anchor="ctr"/>
+          <a:lstStyle/>
+          <a:p>
+            <a:pPr algn="ctr"/>
+          </a:p>
+        </p:txBody>
+      </p:sp>
+      <p:sp>
+        <p:nvSpPr>
+          <p:cNvPr id="14" name="TextBox 13"/>
           <p:cNvSpPr txBox="1"/>
           <p:nvPr/>
         </p:nvSpPr>
         <p:spPr>
           <a:xfrm>
-            <a:off x="548640" y="1188720"/>
-            <a:ext cx="7315200" cy="365760"/>
+            <a:off x="684000" y="6389998"/>
+            <a:ext cx="6480000" cy="216000"/>
           </a:xfrm>
           <a:prstGeom prst="rect">
             <a:avLst/>
@@ -3850,29 +5239,29 @@
           </a:bodyPr>
           <a:lstStyle/>
           <a:p>
-            <a:pPr>
-              <a:defRPr sz="2000" b="1">
+            <a:pPr algn="l">
+              <a:defRPr sz="1500" b="1">
                 <a:solidFill>
                   <a:srgbClr val="1A1A1A"/>
                 </a:solidFill>
               </a:defRPr>
             </a:pPr>
             <a:r>
-              <a:t>AI训练负责人  |  草图里（广州）科技有限公司</a:t>
-            </a:r>
-          </a:p>
-        </p:txBody>
-      </p:sp>
-      <p:sp>
-        <p:nvSpPr>
-          <p:cNvPr id="4" name="TextBox 3"/>
+              <a:t>教育背景</a:t>
+            </a:r>
+          </a:p>
+        </p:txBody>
+      </p:sp>
+      <p:sp>
+        <p:nvSpPr>
+          <p:cNvPr id="15" name="TextBox 14"/>
           <p:cNvSpPr txBox="1"/>
           <p:nvPr/>
         </p:nvSpPr>
         <p:spPr>
           <a:xfrm>
-            <a:off x="548640" y="1645920"/>
-            <a:ext cx="3657600" cy="274320"/>
+            <a:off x="540000" y="6695998"/>
+            <a:ext cx="6480000" cy="180000"/>
           </a:xfrm>
           <a:prstGeom prst="rect">
             <a:avLst/>
@@ -3885,159 +5274,35 @@
           </a:bodyPr>
           <a:lstStyle/>
           <a:p>
-            <a:pPr>
-              <a:defRPr sz="1300" b="0">
-                <a:solidFill>
-                  <a:srgbClr val="5A9A5A"/>
+            <a:pPr algn="l">
+              <a:defRPr sz="1200" b="1">
+                <a:solidFill>
+                  <a:srgbClr val="1A1A1A"/>
                 </a:solidFill>
               </a:defRPr>
             </a:pPr>
             <a:r>
-              <a:t>2023.12-2026.01</a:t>
-            </a:r>
-          </a:p>
-        </p:txBody>
-      </p:sp>
-      <p:sp>
-        <p:nvSpPr>
-          <p:cNvPr id="5" name="TextBox 4"/>
-          <p:cNvSpPr txBox="1"/>
-          <p:nvPr/>
-        </p:nvSpPr>
-        <p:spPr>
-          <a:xfrm>
-            <a:off x="548640" y="2103120"/>
-            <a:ext cx="10972800" cy="4114800"/>
-          </a:xfrm>
-          <a:prstGeom prst="rect">
-            <a:avLst/>
-          </a:prstGeom>
-          <a:noFill/>
-        </p:spPr>
-        <p:txBody>
-          <a:bodyPr wrap="square">
-            <a:spAutoFit/>
-          </a:bodyPr>
-          <a:lstStyle/>
-          <a:p>
-            <a:pPr>
-              <a:spcAft>
-                <a:spcPts val="400"/>
-              </a:spcAft>
-              <a:defRPr sz="1300">
-                <a:solidFill>
-                  <a:srgbClr val="1A1A1A"/>
-                </a:solidFill>
-              </a:defRPr>
-            </a:pPr>
-            <a:r>
-              <a:t>• 管理AI训练组与研发组（10+人），建立招聘-培训-考核全流程管理体系，团队交付效率提升40%</a:t>
-            </a:r>
-          </a:p>
-          <a:p>
-            <a:pPr>
-              <a:spcAft>
-                <a:spcPts val="400"/>
-              </a:spcAft>
-              <a:defRPr sz="1300">
-                <a:solidFill>
-                  <a:srgbClr val="1A1A1A"/>
-                </a:solidFill>
-              </a:defRPr>
-            </a:pPr>
-            <a:r>
-              <a:t>• 主导搭建ComfyUI标准化工作流库，整理70+工作流文档并推动产品化，工作流复用率从15%提升至75%</a:t>
-            </a:r>
-          </a:p>
-          <a:p>
-            <a:pPr>
-              <a:spcAft>
-                <a:spcPts val="400"/>
-              </a:spcAft>
-              <a:defRPr sz="1300">
-                <a:solidFill>
-                  <a:srgbClr val="1A1A1A"/>
-                </a:solidFill>
-              </a:defRPr>
-            </a:pPr>
-            <a:r>
-              <a:t>• 建立研发工作评估审核机制，将模型交付质量评分从平均6.8分提升至8.5分（10分制）</a:t>
-            </a:r>
-          </a:p>
-          <a:p>
-            <a:pPr>
-              <a:spcAft>
-                <a:spcPts val="400"/>
-              </a:spcAft>
-              <a:defRPr sz="1300">
-                <a:solidFill>
-                  <a:srgbClr val="1A1A1A"/>
-                </a:solidFill>
-              </a:defRPr>
-            </a:pPr>
-            <a:r>
-              <a:t>• 持续跟踪Flux、Nano Banana等前沿AI工具，输出12+份技术评估报告，推动3项关键技术选型决策</a:t>
-            </a:r>
-          </a:p>
-          <a:p>
-            <a:pPr>
-              <a:spcAft>
-                <a:spcPts val="400"/>
-              </a:spcAft>
-              <a:defRPr sz="1300">
-                <a:solidFill>
-                  <a:srgbClr val="1A1A1A"/>
-                </a:solidFill>
-              </a:defRPr>
-            </a:pPr>
-            <a:r>
-              <a:t>• 实现从单张参考图到批量出图的完整自动化管线，将客户项目出图周期缩短60%</a:t>
-            </a:r>
-          </a:p>
-        </p:txBody>
-      </p:sp>
-    </p:spTree>
-  </p:cSld>
-  <p:clrMapOvr>
-    <a:masterClrMapping/>
-  </p:clrMapOvr>
-</p:sld>
-</file>
-
-<file path=ppt/slides/slide4.xml><?xml version="1.0" encoding="utf-8"?>
-<p:sld xmlns:a="http://schemas.openxmlformats.org/drawingml/2006/main" xmlns:p="http://schemas.openxmlformats.org/presentationml/2006/main" xmlns:r="http://schemas.openxmlformats.org/officeDocument/2006/relationships">
-  <p:cSld>
-    <p:bg>
-      <p:bgPr>
-        <a:solidFill>
-          <a:srgbClr val="FFFFFF"/>
-        </a:solidFill>
-        <a:effectLst/>
-      </p:bgPr>
-    </p:bg>
-    <p:spTree>
-      <p:nvGrpSpPr>
-        <p:cNvPr id="1" name=""/>
-        <p:cNvGrpSpPr/>
-        <p:nvPr/>
-      </p:nvGrpSpPr>
-      <p:grpSpPr/>
-      <p:sp>
-        <p:nvSpPr>
-          <p:cNvPr id="2" name="Rectangle 1"/>
+              <a:t>仲恺农业工程学院  |  本科  |  园林（设计）</a:t>
+            </a:r>
+          </a:p>
+        </p:txBody>
+      </p:sp>
+      <p:sp>
+        <p:nvSpPr>
+          <p:cNvPr id="16" name="Rectangle 15"/>
           <p:cNvSpPr/>
           <p:nvPr/>
         </p:nvSpPr>
         <p:spPr>
           <a:xfrm>
-            <a:off x="0" y="0"/>
-            <a:ext cx="12191695" cy="914400"/>
+            <a:off x="540000" y="6983998"/>
+            <a:ext cx="54000" cy="251999"/>
           </a:xfrm>
           <a:prstGeom prst="rect">
             <a:avLst/>
           </a:prstGeom>
           <a:solidFill>
-            <a:srgbClr val="F0EFE8"/>
+            <a:srgbClr val="5A9A5A"/>
           </a:solidFill>
           <a:ln>
             <a:noFill/>
@@ -4058,32 +5323,23 @@
           </a:fontRef>
         </p:style>
         <p:txBody>
-          <a:bodyPr rtlCol="0" anchor="ctr" wrap="square" lIns="548640" tIns="137160"/>
-          <a:lstStyle/>
-          <a:p>
-            <a:pPr algn="l">
-              <a:defRPr sz="2800" b="1">
-                <a:solidFill>
-                  <a:srgbClr val="1A1A1A"/>
-                </a:solidFill>
-              </a:defRPr>
-            </a:pPr>
-            <a:r>
-              <a:t>工作经历 2/3</a:t>
-            </a:r>
-          </a:p>
-        </p:txBody>
-      </p:sp>
-      <p:sp>
-        <p:nvSpPr>
-          <p:cNvPr id="3" name="TextBox 2"/>
+          <a:bodyPr rtlCol="0" anchor="ctr"/>
+          <a:lstStyle/>
+          <a:p>
+            <a:pPr algn="ctr"/>
+          </a:p>
+        </p:txBody>
+      </p:sp>
+      <p:sp>
+        <p:nvSpPr>
+          <p:cNvPr id="17" name="TextBox 16"/>
           <p:cNvSpPr txBox="1"/>
           <p:nvPr/>
         </p:nvSpPr>
         <p:spPr>
           <a:xfrm>
-            <a:off x="548640" y="1188720"/>
-            <a:ext cx="7315200" cy="365760"/>
+            <a:off x="684000" y="7001998"/>
+            <a:ext cx="6480000" cy="216000"/>
           </a:xfrm>
           <a:prstGeom prst="rect">
             <a:avLst/>
@@ -4096,29 +5352,29 @@
           </a:bodyPr>
           <a:lstStyle/>
           <a:p>
-            <a:pPr>
-              <a:defRPr sz="2000" b="1">
+            <a:pPr algn="l">
+              <a:defRPr sz="1500" b="1">
                 <a:solidFill>
                   <a:srgbClr val="1A1A1A"/>
                 </a:solidFill>
               </a:defRPr>
             </a:pPr>
             <a:r>
-              <a:t>AI训练师  |  深圳安达曼科技有限公司</a:t>
-            </a:r>
-          </a:p>
-        </p:txBody>
-      </p:sp>
-      <p:sp>
-        <p:nvSpPr>
-          <p:cNvPr id="4" name="TextBox 3"/>
+              <a:t>作品集 &amp; 社区</a:t>
+            </a:r>
+          </a:p>
+        </p:txBody>
+      </p:sp>
+      <p:sp>
+        <p:nvSpPr>
+          <p:cNvPr id="18" name="TextBox 17"/>
           <p:cNvSpPr txBox="1"/>
           <p:nvPr/>
         </p:nvSpPr>
         <p:spPr>
           <a:xfrm>
-            <a:off x="548640" y="1645920"/>
-            <a:ext cx="3657600" cy="274320"/>
+            <a:off x="540000" y="7307998"/>
+            <a:ext cx="6480000" cy="216000"/>
           </a:xfrm>
           <a:prstGeom prst="rect">
             <a:avLst/>
@@ -4131,129 +5387,32 @@
           </a:bodyPr>
           <a:lstStyle/>
           <a:p>
-            <a:pPr>
-              <a:defRPr sz="1300" b="0">
-                <a:solidFill>
-                  <a:srgbClr val="5A9A5A"/>
+            <a:pPr algn="l">
+              <a:defRPr sz="1000" b="0">
+                <a:solidFill>
+                  <a:srgbClr val="555555"/>
                 </a:solidFill>
               </a:defRPr>
             </a:pPr>
-            <a:r>
-              <a:t>2026.03-2026.06</a:t>
-            </a:r>
-          </a:p>
-        </p:txBody>
-      </p:sp>
-      <p:sp>
-        <p:nvSpPr>
-          <p:cNvPr id="5" name="TextBox 4"/>
-          <p:cNvSpPr txBox="1"/>
-          <p:nvPr/>
-        </p:nvSpPr>
-        <p:spPr>
-          <a:xfrm>
-            <a:off x="548640" y="2103120"/>
-            <a:ext cx="10972800" cy="4114800"/>
-          </a:xfrm>
-          <a:prstGeom prst="rect">
-            <a:avLst/>
-          </a:prstGeom>
-          <a:noFill/>
-        </p:spPr>
-        <p:txBody>
-          <a:bodyPr wrap="square">
-            <a:spAutoFit/>
-          </a:bodyPr>
-          <a:lstStyle/>
-          <a:p>
-            <a:pPr>
-              <a:spcAft>
-                <a:spcPts val="400"/>
-              </a:spcAft>
-              <a:defRPr sz="1300">
-                <a:solidFill>
-                  <a:srgbClr val="1A1A1A"/>
-                </a:solidFill>
-              </a:defRPr>
-            </a:pPr>
-            <a:r>
-              <a:t>• 负责AI模型训练及ComfyUI工作流搭建，快速复用草图里时期积累的标准化流程</a:t>
-            </a:r>
-          </a:p>
-          <a:p>
-            <a:pPr>
-              <a:spcAft>
-                <a:spcPts val="400"/>
-              </a:spcAft>
-              <a:defRPr sz="1300">
-                <a:solidFill>
-                  <a:srgbClr val="1A1A1A"/>
-                </a:solidFill>
-              </a:defRPr>
-            </a:pPr>
-            <a:r>
-              <a:t>• 探索实践AI Agent自动化工具链（Claude Code/Codex/Open Claw），探索AI编程与内容创作融合场景</a:t>
-            </a:r>
-          </a:p>
-          <a:p>
-            <a:pPr>
-              <a:spcAft>
-                <a:spcPts val="400"/>
-              </a:spcAft>
-              <a:defRPr sz="1300">
-                <a:solidFill>
-                  <a:srgbClr val="1A1A1A"/>
-                </a:solidFill>
-              </a:defRPr>
-            </a:pPr>
-            <a:r>
-              <a:t>• 岗位发展不符合未来趋势，离职后聚焦AI科技自媒体方向，将技术积累转化为内容影响力</a:t>
-            </a:r>
-          </a:p>
-        </p:txBody>
-      </p:sp>
-    </p:spTree>
-  </p:cSld>
-  <p:clrMapOvr>
-    <a:masterClrMapping/>
-  </p:clrMapOvr>
-</p:sld>
-</file>
-
-<file path=ppt/slides/slide5.xml><?xml version="1.0" encoding="utf-8"?>
-<p:sld xmlns:a="http://schemas.openxmlformats.org/drawingml/2006/main" xmlns:p="http://schemas.openxmlformats.org/presentationml/2006/main" xmlns:r="http://schemas.openxmlformats.org/officeDocument/2006/relationships">
-  <p:cSld>
-    <p:bg>
-      <p:bgPr>
-        <a:solidFill>
-          <a:srgbClr val="FFFFFF"/>
-        </a:solidFill>
-        <a:effectLst/>
-      </p:bgPr>
-    </p:bg>
-    <p:spTree>
-      <p:nvGrpSpPr>
-        <p:cNvPr id="1" name=""/>
-        <p:cNvGrpSpPr/>
-        <p:nvPr/>
-      </p:nvGrpSpPr>
-      <p:grpSpPr/>
-      <p:sp>
-        <p:nvSpPr>
-          <p:cNvPr id="2" name="Rectangle 1"/>
+          </a:p>
+        </p:txBody>
+      </p:sp>
+      <p:sp>
+        <p:nvSpPr>
+          <p:cNvPr id="19" name="Rectangle 18"/>
           <p:cNvSpPr/>
           <p:nvPr/>
         </p:nvSpPr>
         <p:spPr>
           <a:xfrm>
-            <a:off x="0" y="0"/>
-            <a:ext cx="12191695" cy="914400"/>
+            <a:off x="540000" y="7667998"/>
+            <a:ext cx="54000" cy="251999"/>
           </a:xfrm>
           <a:prstGeom prst="rect">
             <a:avLst/>
           </a:prstGeom>
           <a:solidFill>
-            <a:srgbClr val="F0EFE8"/>
+            <a:srgbClr val="5A9A5A"/>
           </a:solidFill>
           <a:ln>
             <a:noFill/>
@@ -4274,32 +5433,23 @@
           </a:fontRef>
         </p:style>
         <p:txBody>
-          <a:bodyPr rtlCol="0" anchor="ctr" wrap="square" lIns="548640" tIns="137160"/>
-          <a:lstStyle/>
-          <a:p>
-            <a:pPr algn="l">
-              <a:defRPr sz="2800" b="1">
-                <a:solidFill>
-                  <a:srgbClr val="1A1A1A"/>
-                </a:solidFill>
-              </a:defRPr>
-            </a:pPr>
-            <a:r>
-              <a:t>工作经历 3/3</a:t>
-            </a:r>
-          </a:p>
-        </p:txBody>
-      </p:sp>
-      <p:sp>
-        <p:nvSpPr>
-          <p:cNvPr id="3" name="TextBox 2"/>
+          <a:bodyPr rtlCol="0" anchor="ctr"/>
+          <a:lstStyle/>
+          <a:p>
+            <a:pPr algn="ctr"/>
+          </a:p>
+        </p:txBody>
+      </p:sp>
+      <p:sp>
+        <p:nvSpPr>
+          <p:cNvPr id="20" name="TextBox 19"/>
           <p:cNvSpPr txBox="1"/>
           <p:nvPr/>
         </p:nvSpPr>
         <p:spPr>
           <a:xfrm>
-            <a:off x="548640" y="1188720"/>
-            <a:ext cx="7315200" cy="365760"/>
+            <a:off x="684000" y="7685998"/>
+            <a:ext cx="6480000" cy="216000"/>
           </a:xfrm>
           <a:prstGeom prst="rect">
             <a:avLst/>
@@ -4312,64 +5462,29 @@
           </a:bodyPr>
           <a:lstStyle/>
           <a:p>
-            <a:pPr>
-              <a:defRPr sz="2000" b="1">
+            <a:pPr algn="l">
+              <a:defRPr sz="1500" b="1">
                 <a:solidFill>
                   <a:srgbClr val="1A1A1A"/>
                 </a:solidFill>
               </a:defRPr>
             </a:pPr>
             <a:r>
-              <a:t>AIGC技术应用与行业实践  |  </a:t>
-            </a:r>
-          </a:p>
-        </p:txBody>
-      </p:sp>
-      <p:sp>
-        <p:nvSpPr>
-          <p:cNvPr id="4" name="TextBox 3"/>
+              <a:t>求职意向</a:t>
+            </a:r>
+          </a:p>
+        </p:txBody>
+      </p:sp>
+      <p:sp>
+        <p:nvSpPr>
+          <p:cNvPr id="21" name="TextBox 20"/>
           <p:cNvSpPr txBox="1"/>
           <p:nvPr/>
         </p:nvSpPr>
         <p:spPr>
           <a:xfrm>
-            <a:off x="548640" y="1645920"/>
-            <a:ext cx="3657600" cy="274320"/>
-          </a:xfrm>
-          <a:prstGeom prst="rect">
-            <a:avLst/>
-          </a:prstGeom>
-          <a:noFill/>
-        </p:spPr>
-        <p:txBody>
-          <a:bodyPr wrap="square">
-            <a:spAutoFit/>
-          </a:bodyPr>
-          <a:lstStyle/>
-          <a:p>
-            <a:pPr>
-              <a:defRPr sz="1300" b="0">
-                <a:solidFill>
-                  <a:srgbClr val="5A9A5A"/>
-                </a:solidFill>
-              </a:defRPr>
-            </a:pPr>
-            <a:r>
-              <a:t>2022.12-2023.12</a:t>
-            </a:r>
-          </a:p>
-        </p:txBody>
-      </p:sp>
-      <p:sp>
-        <p:nvSpPr>
-          <p:cNvPr id="5" name="TextBox 4"/>
-          <p:cNvSpPr txBox="1"/>
-          <p:nvPr/>
-        </p:nvSpPr>
-        <p:spPr>
-          <a:xfrm>
-            <a:off x="548640" y="2103120"/>
-            <a:ext cx="10972800" cy="4114800"/>
+            <a:off x="540000" y="7991998"/>
+            <a:ext cx="6480000" cy="540000"/>
           </a:xfrm>
           <a:prstGeom prst="rect">
             <a:avLst/>
@@ -4386,14 +5501,14 @@
               <a:spcAft>
                 <a:spcPts val="400"/>
               </a:spcAft>
-              <a:defRPr sz="1300">
+              <a:defRPr sz="1100">
                 <a:solidFill>
                   <a:srgbClr val="1A1A1A"/>
                 </a:solidFill>
               </a:defRPr>
             </a:pPr>
             <a:r>
-              <a:t>• 在B站持续输入AIGC前沿内容，累计发布50篇AI教程笔记，阅读量16万+</a:t>
+              <a:t>目标岗位: AIGC内容创作 / AI科技自媒体团队成员</a:t>
             </a:r>
           </a:p>
           <a:p>
@@ -4401,14 +5516,14 @@
               <a:spcAft>
                 <a:spcPts val="400"/>
               </a:spcAft>
-              <a:defRPr sz="1300">
+              <a:defRPr sz="1100">
                 <a:solidFill>
                   <a:srgbClr val="1A1A1A"/>
                 </a:solidFill>
               </a:defRPr>
             </a:pPr>
             <a:r>
-              <a:t>• 先后为2家企业搭建AIGC设计管线，将AI绘画工具引入实际业务流程，设计出图效率提升50%</a:t>
+              <a:t>期望薪资: 15-20K</a:t>
             </a:r>
           </a:p>
           <a:p>
@@ -4416,106 +5531,28 @@
               <a:spcAft>
                 <a:spcPts val="400"/>
               </a:spcAft>
-              <a:defRPr sz="1300">
+              <a:defRPr sz="1100">
                 <a:solidFill>
                   <a:srgbClr val="1A1A1A"/>
                 </a:solidFill>
               </a:defRPr>
             </a:pPr>
             <a:r>
-              <a:t>• 独立完成从技术调研、方案设计到落地培训的全流程，为后续标准化工作流体系奠定核心基础</a:t>
-            </a:r>
-          </a:p>
-        </p:txBody>
-      </p:sp>
-    </p:spTree>
-  </p:cSld>
-  <p:clrMapOvr>
-    <a:masterClrMapping/>
-  </p:clrMapOvr>
-</p:sld>
-</file>
-
-<file path=ppt/slides/slide6.xml><?xml version="1.0" encoding="utf-8"?>
-<p:sld xmlns:a="http://schemas.openxmlformats.org/drawingml/2006/main" xmlns:p="http://schemas.openxmlformats.org/presentationml/2006/main" xmlns:r="http://schemas.openxmlformats.org/officeDocument/2006/relationships">
-  <p:cSld>
-    <p:bg>
-      <p:bgPr>
-        <a:solidFill>
-          <a:srgbClr val="FFFFFF"/>
-        </a:solidFill>
-        <a:effectLst/>
-      </p:bgPr>
-    </p:bg>
-    <p:spTree>
-      <p:nvGrpSpPr>
-        <p:cNvPr id="1" name=""/>
-        <p:cNvGrpSpPr/>
-        <p:nvPr/>
-      </p:nvGrpSpPr>
-      <p:grpSpPr/>
-      <p:sp>
-        <p:nvSpPr>
-          <p:cNvPr id="2" name="Rectangle 1"/>
-          <p:cNvSpPr/>
-          <p:nvPr/>
-        </p:nvSpPr>
-        <p:spPr>
-          <a:xfrm>
-            <a:off x="0" y="0"/>
-            <a:ext cx="12191695" cy="914400"/>
-          </a:xfrm>
-          <a:prstGeom prst="rect">
-            <a:avLst/>
-          </a:prstGeom>
-          <a:solidFill>
-            <a:srgbClr val="F0EFE8"/>
-          </a:solidFill>
-          <a:ln>
-            <a:noFill/>
-          </a:ln>
-        </p:spPr>
-        <p:style>
-          <a:lnRef idx="1">
-            <a:schemeClr val="accent1"/>
-          </a:lnRef>
-          <a:fillRef idx="3">
-            <a:schemeClr val="accent1"/>
-          </a:fillRef>
-          <a:effectRef idx="2">
-            <a:schemeClr val="accent1"/>
-          </a:effectRef>
-          <a:fontRef idx="minor">
-            <a:schemeClr val="lt1"/>
-          </a:fontRef>
-        </p:style>
-        <p:txBody>
-          <a:bodyPr rtlCol="0" anchor="ctr" wrap="square" lIns="548640" tIns="137160"/>
-          <a:lstStyle/>
-          <a:p>
-            <a:pPr algn="l">
-              <a:defRPr sz="2800" b="1">
-                <a:solidFill>
-                  <a:srgbClr val="1A1A1A"/>
-                </a:solidFill>
-              </a:defRPr>
-            </a:pPr>
-            <a:r>
-              <a:t>项目经验 1/3</a:t>
-            </a:r>
-          </a:p>
-        </p:txBody>
-      </p:sp>
-      <p:sp>
-        <p:nvSpPr>
-          <p:cNvPr id="3" name="TextBox 2"/>
+              <a:t>工作类型: 全职</a:t>
+            </a:r>
+          </a:p>
+        </p:txBody>
+      </p:sp>
+      <p:sp>
+        <p:nvSpPr>
+          <p:cNvPr id="22" name="TextBox 21"/>
           <p:cNvSpPr txBox="1"/>
           <p:nvPr/>
         </p:nvSpPr>
         <p:spPr>
           <a:xfrm>
-            <a:off x="548640" y="1188720"/>
-            <a:ext cx="9144000" cy="365760"/>
+            <a:off x="540000" y="10260000"/>
+            <a:ext cx="6480000" cy="180000"/>
           </a:xfrm>
           <a:prstGeom prst="rect">
             <a:avLst/>
@@ -4528,788 +5565,15 @@
           </a:bodyPr>
           <a:lstStyle/>
           <a:p>
-            <a:pPr>
-              <a:defRPr sz="2000" b="1">
-                <a:solidFill>
-                  <a:srgbClr val="1A1A1A"/>
+            <a:pPr algn="ctr">
+              <a:defRPr sz="900" b="0">
+                <a:solidFill>
+                  <a:srgbClr val="888888"/>
                 </a:solidFill>
               </a:defRPr>
             </a:pPr>
             <a:r>
-              <a:t>novel-factory：AI长篇小说自动写作与发布系统</a:t>
-            </a:r>
-          </a:p>
-        </p:txBody>
-      </p:sp>
-      <p:sp>
-        <p:nvSpPr>
-          <p:cNvPr id="4" name="TextBox 3"/>
-          <p:cNvSpPr txBox="1"/>
-          <p:nvPr/>
-        </p:nvSpPr>
-        <p:spPr>
-          <a:xfrm>
-            <a:off x="548640" y="1554480"/>
-            <a:ext cx="7315200" cy="274320"/>
-          </a:xfrm>
-          <a:prstGeom prst="rect">
-            <a:avLst/>
-          </a:prstGeom>
-          <a:noFill/>
-        </p:spPr>
-        <p:txBody>
-          <a:bodyPr wrap="square">
-            <a:spAutoFit/>
-          </a:bodyPr>
-          <a:lstStyle/>
-          <a:p>
-            <a:pPr>
-              <a:defRPr sz="1300" b="0">
-                <a:solidFill>
-                  <a:srgbClr val="5A9A5A"/>
-                </a:solidFill>
-              </a:defRPr>
-            </a:pPr>
-            <a:r>
-              <a:t>独立开发者</a:t>
-            </a:r>
-          </a:p>
-        </p:txBody>
-      </p:sp>
-      <p:sp>
-        <p:nvSpPr>
-          <p:cNvPr id="5" name="TextBox 4"/>
-          <p:cNvSpPr txBox="1"/>
-          <p:nvPr/>
-        </p:nvSpPr>
-        <p:spPr>
-          <a:xfrm>
-            <a:off x="548640" y="2011680"/>
-            <a:ext cx="10972800" cy="4389120"/>
-          </a:xfrm>
-          <a:prstGeom prst="rect">
-            <a:avLst/>
-          </a:prstGeom>
-          <a:noFill/>
-        </p:spPr>
-        <p:txBody>
-          <a:bodyPr wrap="square">
-            <a:spAutoFit/>
-          </a:bodyPr>
-          <a:lstStyle/>
-          <a:p>
-            <a:pPr>
-              <a:spcAft>
-                <a:spcPts val="400"/>
-              </a:spcAft>
-              <a:defRPr sz="1300">
-                <a:solidFill>
-                  <a:srgbClr val="1A1A1A"/>
-                </a:solidFill>
-              </a:defRPr>
-            </a:pPr>
-            <a:r>
-              <a:t>• 设计AI作者/编辑/审校多Agent协作架构，实现从选题→写作→审校→发布的完整自动化链路</a:t>
-            </a:r>
-          </a:p>
-          <a:p>
-            <a:pPr>
-              <a:spcAft>
-                <a:spcPts val="400"/>
-              </a:spcAft>
-              <a:defRPr sz="1300">
-                <a:solidFill>
-                  <a:srgbClr val="1A1A1A"/>
-                </a:solidFill>
-              </a:defRPr>
-            </a:pPr>
-            <a:r>
-              <a:t>• 集成飞书文档API实现云端同步存储，支持定时发布调度，单次可生成10万字长篇小说</a:t>
-            </a:r>
-          </a:p>
-          <a:p>
-            <a:pPr>
-              <a:spcAft>
-                <a:spcPts val="400"/>
-              </a:spcAft>
-              <a:defRPr sz="1300">
-                <a:solidFill>
-                  <a:srgbClr val="1A1A1A"/>
-                </a:solidFill>
-              </a:defRPr>
-            </a:pPr>
-            <a:r>
-              <a:t>• 部署在Linux服务器（systemd守护进程），实现7×24小时无人值守运行</a:t>
-            </a:r>
-          </a:p>
-        </p:txBody>
-      </p:sp>
-    </p:spTree>
-  </p:cSld>
-  <p:clrMapOvr>
-    <a:masterClrMapping/>
-  </p:clrMapOvr>
-</p:sld>
-</file>
-
-<file path=ppt/slides/slide7.xml><?xml version="1.0" encoding="utf-8"?>
-<p:sld xmlns:a="http://schemas.openxmlformats.org/drawingml/2006/main" xmlns:p="http://schemas.openxmlformats.org/presentationml/2006/main" xmlns:r="http://schemas.openxmlformats.org/officeDocument/2006/relationships">
-  <p:cSld>
-    <p:bg>
-      <p:bgPr>
-        <a:solidFill>
-          <a:srgbClr val="FFFFFF"/>
-        </a:solidFill>
-        <a:effectLst/>
-      </p:bgPr>
-    </p:bg>
-    <p:spTree>
-      <p:nvGrpSpPr>
-        <p:cNvPr id="1" name=""/>
-        <p:cNvGrpSpPr/>
-        <p:nvPr/>
-      </p:nvGrpSpPr>
-      <p:grpSpPr/>
-      <p:sp>
-        <p:nvSpPr>
-          <p:cNvPr id="2" name="Rectangle 1"/>
-          <p:cNvSpPr/>
-          <p:nvPr/>
-        </p:nvSpPr>
-        <p:spPr>
-          <a:xfrm>
-            <a:off x="0" y="0"/>
-            <a:ext cx="12191695" cy="914400"/>
-          </a:xfrm>
-          <a:prstGeom prst="rect">
-            <a:avLst/>
-          </a:prstGeom>
-          <a:solidFill>
-            <a:srgbClr val="F0EFE8"/>
-          </a:solidFill>
-          <a:ln>
-            <a:noFill/>
-          </a:ln>
-        </p:spPr>
-        <p:style>
-          <a:lnRef idx="1">
-            <a:schemeClr val="accent1"/>
-          </a:lnRef>
-          <a:fillRef idx="3">
-            <a:schemeClr val="accent1"/>
-          </a:fillRef>
-          <a:effectRef idx="2">
-            <a:schemeClr val="accent1"/>
-          </a:effectRef>
-          <a:fontRef idx="minor">
-            <a:schemeClr val="lt1"/>
-          </a:fontRef>
-        </p:style>
-        <p:txBody>
-          <a:bodyPr rtlCol="0" anchor="ctr" wrap="square" lIns="548640" tIns="137160"/>
-          <a:lstStyle/>
-          <a:p>
-            <a:pPr algn="l">
-              <a:defRPr sz="2800" b="1">
-                <a:solidFill>
-                  <a:srgbClr val="1A1A1A"/>
-                </a:solidFill>
-              </a:defRPr>
-            </a:pPr>
-            <a:r>
-              <a:t>项目经验 2/3</a:t>
-            </a:r>
-          </a:p>
-        </p:txBody>
-      </p:sp>
-      <p:sp>
-        <p:nvSpPr>
-          <p:cNvPr id="3" name="TextBox 2"/>
-          <p:cNvSpPr txBox="1"/>
-          <p:nvPr/>
-        </p:nvSpPr>
-        <p:spPr>
-          <a:xfrm>
-            <a:off x="548640" y="1188720"/>
-            <a:ext cx="9144000" cy="365760"/>
-          </a:xfrm>
-          <a:prstGeom prst="rect">
-            <a:avLst/>
-          </a:prstGeom>
-          <a:noFill/>
-        </p:spPr>
-        <p:txBody>
-          <a:bodyPr wrap="square">
-            <a:spAutoFit/>
-          </a:bodyPr>
-          <a:lstStyle/>
-          <a:p>
-            <a:pPr>
-              <a:defRPr sz="2000" b="1">
-                <a:solidFill>
-                  <a:srgbClr val="1A1A1A"/>
-                </a:solidFill>
-              </a:defRPr>
-            </a:pPr>
-            <a:r>
-              <a:t>bilibili-to-feishu-note-bot：B站视频→飞书AI笔记机器人</a:t>
-            </a:r>
-          </a:p>
-        </p:txBody>
-      </p:sp>
-      <p:sp>
-        <p:nvSpPr>
-          <p:cNvPr id="4" name="TextBox 3"/>
-          <p:cNvSpPr txBox="1"/>
-          <p:nvPr/>
-        </p:nvSpPr>
-        <p:spPr>
-          <a:xfrm>
-            <a:off x="548640" y="1554480"/>
-            <a:ext cx="7315200" cy="274320"/>
-          </a:xfrm>
-          <a:prstGeom prst="rect">
-            <a:avLst/>
-          </a:prstGeom>
-          <a:noFill/>
-        </p:spPr>
-        <p:txBody>
-          <a:bodyPr wrap="square">
-            <a:spAutoFit/>
-          </a:bodyPr>
-          <a:lstStyle/>
-          <a:p>
-            <a:pPr>
-              <a:defRPr sz="1300" b="0">
-                <a:solidFill>
-                  <a:srgbClr val="5A9A5A"/>
-                </a:solidFill>
-              </a:defRPr>
-            </a:pPr>
-            <a:r>
-              <a:t>独立开发者</a:t>
-            </a:r>
-          </a:p>
-        </p:txBody>
-      </p:sp>
-      <p:sp>
-        <p:nvSpPr>
-          <p:cNvPr id="5" name="TextBox 4"/>
-          <p:cNvSpPr txBox="1"/>
-          <p:nvPr/>
-        </p:nvSpPr>
-        <p:spPr>
-          <a:xfrm>
-            <a:off x="548640" y="2011680"/>
-            <a:ext cx="10972800" cy="4389120"/>
-          </a:xfrm>
-          <a:prstGeom prst="rect">
-            <a:avLst/>
-          </a:prstGeom>
-          <a:noFill/>
-        </p:spPr>
-        <p:txBody>
-          <a:bodyPr wrap="square">
-            <a:spAutoFit/>
-          </a:bodyPr>
-          <a:lstStyle/>
-          <a:p>
-            <a:pPr>
-              <a:spcAft>
-                <a:spcPts val="400"/>
-              </a:spcAft>
-              <a:defRPr sz="1300">
-                <a:solidFill>
-                  <a:srgbClr val="1A1A1A"/>
-                </a:solidFill>
-              </a:defRPr>
-            </a:pPr>
-            <a:r>
-              <a:t>• 实现B站视频自动下载→音频提取→Whisper语音转录→DeepSeek结构化笔记生成的全流程自动化</a:t>
-            </a:r>
-          </a:p>
-          <a:p>
-            <a:pPr>
-              <a:spcAft>
-                <a:spcPts val="400"/>
-              </a:spcAft>
-              <a:defRPr sz="1300">
-                <a:solidFill>
-                  <a:srgbClr val="1A1A1A"/>
-                </a:solidFill>
-              </a:defRPr>
-            </a:pPr>
-            <a:r>
-              <a:t>• 自动生成带时间戳、关键观点、思维导图的结构化飞书文档，笔记生成准确率达90%+</a:t>
-            </a:r>
-          </a:p>
-          <a:p>
-            <a:pPr>
-              <a:spcAft>
-                <a:spcPts val="400"/>
-              </a:spcAft>
-              <a:defRPr sz="1300">
-                <a:solidFill>
-                  <a:srgbClr val="1A1A1A"/>
-                </a:solidFill>
-              </a:defRPr>
-            </a:pPr>
-            <a:r>
-              <a:t>• 支持定时监控UP主更新，自动触发笔记生成流程，累计处理视频500+个</a:t>
-            </a:r>
-          </a:p>
-        </p:txBody>
-      </p:sp>
-    </p:spTree>
-  </p:cSld>
-  <p:clrMapOvr>
-    <a:masterClrMapping/>
-  </p:clrMapOvr>
-</p:sld>
-</file>
-
-<file path=ppt/slides/slide8.xml><?xml version="1.0" encoding="utf-8"?>
-<p:sld xmlns:a="http://schemas.openxmlformats.org/drawingml/2006/main" xmlns:p="http://schemas.openxmlformats.org/presentationml/2006/main" xmlns:r="http://schemas.openxmlformats.org/officeDocument/2006/relationships">
-  <p:cSld>
-    <p:bg>
-      <p:bgPr>
-        <a:solidFill>
-          <a:srgbClr val="FFFFFF"/>
-        </a:solidFill>
-        <a:effectLst/>
-      </p:bgPr>
-    </p:bg>
-    <p:spTree>
-      <p:nvGrpSpPr>
-        <p:cNvPr id="1" name=""/>
-        <p:cNvGrpSpPr/>
-        <p:nvPr/>
-      </p:nvGrpSpPr>
-      <p:grpSpPr/>
-      <p:sp>
-        <p:nvSpPr>
-          <p:cNvPr id="2" name="Rectangle 1"/>
-          <p:cNvSpPr/>
-          <p:nvPr/>
-        </p:nvSpPr>
-        <p:spPr>
-          <a:xfrm>
-            <a:off x="0" y="0"/>
-            <a:ext cx="12191695" cy="914400"/>
-          </a:xfrm>
-          <a:prstGeom prst="rect">
-            <a:avLst/>
-          </a:prstGeom>
-          <a:solidFill>
-            <a:srgbClr val="F0EFE8"/>
-          </a:solidFill>
-          <a:ln>
-            <a:noFill/>
-          </a:ln>
-        </p:spPr>
-        <p:style>
-          <a:lnRef idx="1">
-            <a:schemeClr val="accent1"/>
-          </a:lnRef>
-          <a:fillRef idx="3">
-            <a:schemeClr val="accent1"/>
-          </a:fillRef>
-          <a:effectRef idx="2">
-            <a:schemeClr val="accent1"/>
-          </a:effectRef>
-          <a:fontRef idx="minor">
-            <a:schemeClr val="lt1"/>
-          </a:fontRef>
-        </p:style>
-        <p:txBody>
-          <a:bodyPr rtlCol="0" anchor="ctr" wrap="square" lIns="548640" tIns="137160"/>
-          <a:lstStyle/>
-          <a:p>
-            <a:pPr algn="l">
-              <a:defRPr sz="2800" b="1">
-                <a:solidFill>
-                  <a:srgbClr val="1A1A1A"/>
-                </a:solidFill>
-              </a:defRPr>
-            </a:pPr>
-            <a:r>
-              <a:t>项目经验 3/3</a:t>
-            </a:r>
-          </a:p>
-        </p:txBody>
-      </p:sp>
-      <p:sp>
-        <p:nvSpPr>
-          <p:cNvPr id="3" name="TextBox 2"/>
-          <p:cNvSpPr txBox="1"/>
-          <p:nvPr/>
-        </p:nvSpPr>
-        <p:spPr>
-          <a:xfrm>
-            <a:off x="548640" y="1188720"/>
-            <a:ext cx="9144000" cy="365760"/>
-          </a:xfrm>
-          <a:prstGeom prst="rect">
-            <a:avLst/>
-          </a:prstGeom>
-          <a:noFill/>
-        </p:spPr>
-        <p:txBody>
-          <a:bodyPr wrap="square">
-            <a:spAutoFit/>
-          </a:bodyPr>
-          <a:lstStyle/>
-          <a:p>
-            <a:pPr>
-              <a:defRPr sz="2000" b="1">
-                <a:solidFill>
-                  <a:srgbClr val="1A1A1A"/>
-                </a:solidFill>
-              </a:defRPr>
-            </a:pPr>
-            <a:r>
-              <a:t>AI模型发布与社区影响力建设</a:t>
-            </a:r>
-          </a:p>
-        </p:txBody>
-      </p:sp>
-      <p:sp>
-        <p:nvSpPr>
-          <p:cNvPr id="4" name="TextBox 3"/>
-          <p:cNvSpPr txBox="1"/>
-          <p:nvPr/>
-        </p:nvSpPr>
-        <p:spPr>
-          <a:xfrm>
-            <a:off x="548640" y="1554480"/>
-            <a:ext cx="7315200" cy="274320"/>
-          </a:xfrm>
-          <a:prstGeom prst="rect">
-            <a:avLst/>
-          </a:prstGeom>
-          <a:noFill/>
-        </p:spPr>
-        <p:txBody>
-          <a:bodyPr wrap="square">
-            <a:spAutoFit/>
-          </a:bodyPr>
-          <a:lstStyle/>
-          <a:p>
-            <a:pPr>
-              <a:defRPr sz="1300" b="0">
-                <a:solidFill>
-                  <a:srgbClr val="5A9A5A"/>
-                </a:solidFill>
-              </a:defRPr>
-            </a:pPr>
-            <a:r>
-              <a:t>创作者/模型训练师</a:t>
-            </a:r>
-          </a:p>
-        </p:txBody>
-      </p:sp>
-      <p:sp>
-        <p:nvSpPr>
-          <p:cNvPr id="5" name="TextBox 4"/>
-          <p:cNvSpPr txBox="1"/>
-          <p:nvPr/>
-        </p:nvSpPr>
-        <p:spPr>
-          <a:xfrm>
-            <a:off x="548640" y="2011680"/>
-            <a:ext cx="10972800" cy="4389120"/>
-          </a:xfrm>
-          <a:prstGeom prst="rect">
-            <a:avLst/>
-          </a:prstGeom>
-          <a:noFill/>
-        </p:spPr>
-        <p:txBody>
-          <a:bodyPr wrap="square">
-            <a:spAutoFit/>
-          </a:bodyPr>
-          <a:lstStyle/>
-          <a:p>
-            <a:pPr>
-              <a:spcAft>
-                <a:spcPts val="400"/>
-              </a:spcAft>
-              <a:defRPr sz="1300">
-                <a:solidFill>
-                  <a:srgbClr val="1A1A1A"/>
-                </a:solidFill>
-              </a:defRPr>
-            </a:pPr>
-            <a:r>
-              <a:t>• 在Liblib及小红书运营个人AI账号，专注景观/汽车/电商/游戏四大垂直行业LoRA模型</a:t>
-            </a:r>
-          </a:p>
-          <a:p>
-            <a:pPr>
-              <a:spcAft>
-                <a:spcPts val="400"/>
-              </a:spcAft>
-              <a:defRPr sz="1300">
-                <a:solidFill>
-                  <a:srgbClr val="1A1A1A"/>
-                </a:solidFill>
-              </a:defRPr>
-            </a:pPr>
-            <a:r>
-              <a:t>• 发布Lora模型、ComfyUI工作流、AI图片及视频作品50+个，模型总使用次数80K+，获赞1.7K+</a:t>
-            </a:r>
-          </a:p>
-        </p:txBody>
-      </p:sp>
-    </p:spTree>
-  </p:cSld>
-  <p:clrMapOvr>
-    <a:masterClrMapping/>
-  </p:clrMapOvr>
-</p:sld>
-</file>
-
-<file path=ppt/slides/slide9.xml><?xml version="1.0" encoding="utf-8"?>
-<p:sld xmlns:a="http://schemas.openxmlformats.org/drawingml/2006/main" xmlns:p="http://schemas.openxmlformats.org/presentationml/2006/main" xmlns:r="http://schemas.openxmlformats.org/officeDocument/2006/relationships">
-  <p:cSld>
-    <p:bg>
-      <p:bgPr>
-        <a:solidFill>
-          <a:srgbClr val="FFFFFF"/>
-        </a:solidFill>
-        <a:effectLst/>
-      </p:bgPr>
-    </p:bg>
-    <p:spTree>
-      <p:nvGrpSpPr>
-        <p:cNvPr id="1" name=""/>
-        <p:cNvGrpSpPr/>
-        <p:nvPr/>
-      </p:nvGrpSpPr>
-      <p:grpSpPr/>
-      <p:sp>
-        <p:nvSpPr>
-          <p:cNvPr id="2" name="Rectangle 1"/>
-          <p:cNvSpPr/>
-          <p:nvPr/>
-        </p:nvSpPr>
-        <p:spPr>
-          <a:xfrm>
-            <a:off x="0" y="0"/>
-            <a:ext cx="12191695" cy="914400"/>
-          </a:xfrm>
-          <a:prstGeom prst="rect">
-            <a:avLst/>
-          </a:prstGeom>
-          <a:solidFill>
-            <a:srgbClr val="F0EFE8"/>
-          </a:solidFill>
-          <a:ln>
-            <a:noFill/>
-          </a:ln>
-        </p:spPr>
-        <p:style>
-          <a:lnRef idx="1">
-            <a:schemeClr val="accent1"/>
-          </a:lnRef>
-          <a:fillRef idx="3">
-            <a:schemeClr val="accent1"/>
-          </a:fillRef>
-          <a:effectRef idx="2">
-            <a:schemeClr val="accent1"/>
-          </a:effectRef>
-          <a:fontRef idx="minor">
-            <a:schemeClr val="lt1"/>
-          </a:fontRef>
-        </p:style>
-        <p:txBody>
-          <a:bodyPr rtlCol="0" anchor="ctr" wrap="square" lIns="548640" tIns="137160"/>
-          <a:lstStyle/>
-          <a:p>
-            <a:pPr algn="l">
-              <a:defRPr sz="2800" b="1">
-                <a:solidFill>
-                  <a:srgbClr val="1A1A1A"/>
-                </a:solidFill>
-              </a:defRPr>
-            </a:pPr>
-            <a:r>
-              <a:t>教育背景 &amp; 求职意向</a:t>
-            </a:r>
-          </a:p>
-        </p:txBody>
-      </p:sp>
-      <p:sp>
-        <p:nvSpPr>
-          <p:cNvPr id="3" name="TextBox 2"/>
-          <p:cNvSpPr txBox="1"/>
-          <p:nvPr/>
-        </p:nvSpPr>
-        <p:spPr>
-          <a:xfrm>
-            <a:off x="548640" y="1188720"/>
-            <a:ext cx="7315200" cy="365760"/>
-          </a:xfrm>
-          <a:prstGeom prst="rect">
-            <a:avLst/>
-          </a:prstGeom>
-          <a:noFill/>
-        </p:spPr>
-        <p:txBody>
-          <a:bodyPr wrap="square">
-            <a:spAutoFit/>
-          </a:bodyPr>
-          <a:lstStyle/>
-          <a:p>
-            <a:pPr>
-              <a:defRPr sz="2000" b="1">
-                <a:solidFill>
-                  <a:srgbClr val="1A1A1A"/>
-                </a:solidFill>
-              </a:defRPr>
-            </a:pPr>
-            <a:r>
-              <a:t>仲恺农业工程学院  |  本科  |  园林（设计）</a:t>
-            </a:r>
-          </a:p>
-        </p:txBody>
-      </p:sp>
-      <p:sp>
-        <p:nvSpPr>
-          <p:cNvPr id="4" name="TextBox 3"/>
-          <p:cNvSpPr txBox="1"/>
-          <p:nvPr/>
-        </p:nvSpPr>
-        <p:spPr>
-          <a:xfrm>
-            <a:off x="548640" y="2011680"/>
-            <a:ext cx="10972800" cy="365760"/>
-          </a:xfrm>
-          <a:prstGeom prst="rect">
-            <a:avLst/>
-          </a:prstGeom>
-          <a:noFill/>
-        </p:spPr>
-        <p:txBody>
-          <a:bodyPr wrap="square">
-            <a:spAutoFit/>
-          </a:bodyPr>
-          <a:lstStyle/>
-          <a:p>
-            <a:pPr>
-              <a:defRPr sz="1600" b="1">
-                <a:solidFill>
-                  <a:srgbClr val="5A9A5A"/>
-                </a:solidFill>
-              </a:defRPr>
-            </a:pPr>
-            <a:r>
-              <a:t>求职意向</a:t>
-            </a:r>
-          </a:p>
-        </p:txBody>
-      </p:sp>
-      <p:sp>
-        <p:nvSpPr>
-          <p:cNvPr id="5" name="TextBox 4"/>
-          <p:cNvSpPr txBox="1"/>
-          <p:nvPr/>
-        </p:nvSpPr>
-        <p:spPr>
-          <a:xfrm>
-            <a:off x="548640" y="2560320"/>
-            <a:ext cx="10972800" cy="320040"/>
-          </a:xfrm>
-          <a:prstGeom prst="rect">
-            <a:avLst/>
-          </a:prstGeom>
-          <a:noFill/>
-        </p:spPr>
-        <p:txBody>
-          <a:bodyPr wrap="square">
-            <a:spAutoFit/>
-          </a:bodyPr>
-          <a:lstStyle/>
-          <a:p>
-            <a:pPr>
-              <a:defRPr sz="1400" b="0">
-                <a:solidFill>
-                  <a:srgbClr val="1A1A1A"/>
-                </a:solidFill>
-              </a:defRPr>
-            </a:pPr>
-            <a:r>
-              <a:t>目标岗位:  AIGC内容创作 / AI科技自媒体团队成员</a:t>
-            </a:r>
-          </a:p>
-        </p:txBody>
-      </p:sp>
-      <p:sp>
-        <p:nvSpPr>
-          <p:cNvPr id="6" name="TextBox 5"/>
-          <p:cNvSpPr txBox="1"/>
-          <p:nvPr/>
-        </p:nvSpPr>
-        <p:spPr>
-          <a:xfrm>
-            <a:off x="548640" y="2926080"/>
-            <a:ext cx="10972800" cy="320040"/>
-          </a:xfrm>
-          <a:prstGeom prst="rect">
-            <a:avLst/>
-          </a:prstGeom>
-          <a:noFill/>
-        </p:spPr>
-        <p:txBody>
-          <a:bodyPr wrap="square">
-            <a:spAutoFit/>
-          </a:bodyPr>
-          <a:lstStyle/>
-          <a:p>
-            <a:pPr>
-              <a:defRPr sz="1400" b="0">
-                <a:solidFill>
-                  <a:srgbClr val="1A1A1A"/>
-                </a:solidFill>
-              </a:defRPr>
-            </a:pPr>
-            <a:r>
-              <a:t>期望薪资:  15-20K</a:t>
-            </a:r>
-          </a:p>
-        </p:txBody>
-      </p:sp>
-      <p:sp>
-        <p:nvSpPr>
-          <p:cNvPr id="7" name="TextBox 6"/>
-          <p:cNvSpPr txBox="1"/>
-          <p:nvPr/>
-        </p:nvSpPr>
-        <p:spPr>
-          <a:xfrm>
-            <a:off x="548640" y="3291840"/>
-            <a:ext cx="10972800" cy="320040"/>
-          </a:xfrm>
-          <a:prstGeom prst="rect">
-            <a:avLst/>
-          </a:prstGeom>
-          <a:noFill/>
-        </p:spPr>
-        <p:txBody>
-          <a:bodyPr wrap="square">
-            <a:spAutoFit/>
-          </a:bodyPr>
-          <a:lstStyle/>
-          <a:p>
-            <a:pPr>
-              <a:defRPr sz="1400" b="0">
-                <a:solidFill>
-                  <a:srgbClr val="1A1A1A"/>
-                </a:solidFill>
-              </a:defRPr>
-            </a:pPr>
-            <a:r>
-              <a:t>工作类型:  全职</a:t>
+              <a:t>叁十三 · AIGC创作者  |  深圳  |  sanshisanAIGC</a:t>
             </a:r>
           </a:p>
         </p:txBody>

</xml_diff>

<commit_message>
Fix PPT global variables
</commit_message>
<xml_diff>
--- a/docs/resume.pptx
+++ b/docs/resume.pptx
@@ -3412,7 +3412,7 @@
         </p:nvSpPr>
         <p:spPr>
           <a:xfrm>
-            <a:off x="540000" y="2232000"/>
+            <a:off x="540000" y="2160000"/>
             <a:ext cx="54000" cy="251999"/>
           </a:xfrm>
           <a:prstGeom prst="rect">
@@ -3455,7 +3455,7 @@
         </p:nvSpPr>
         <p:spPr>
           <a:xfrm>
-            <a:off x="684000" y="2250000"/>
+            <a:off x="684000" y="2178000"/>
             <a:ext cx="6480000" cy="216000"/>
           </a:xfrm>
           <a:prstGeom prst="rect">
@@ -3490,7 +3490,7 @@
         </p:nvSpPr>
         <p:spPr>
           <a:xfrm>
-            <a:off x="540000" y="2556000"/>
+            <a:off x="540000" y="2484000"/>
             <a:ext cx="648000" cy="180000"/>
           </a:xfrm>
           <a:prstGeom prst="rect">
@@ -3525,7 +3525,7 @@
         </p:nvSpPr>
         <p:spPr>
           <a:xfrm>
-            <a:off x="1332000" y="2574000"/>
+            <a:off x="1332000" y="2502000"/>
             <a:ext cx="2707200" cy="180000"/>
           </a:xfrm>
           <a:prstGeom prst="rect">
@@ -3568,7 +3568,7 @@
         </p:nvSpPr>
         <p:spPr>
           <a:xfrm>
-            <a:off x="1368000" y="2577600"/>
+            <a:off x="1368000" y="2505600"/>
             <a:ext cx="2635200" cy="162000"/>
           </a:xfrm>
           <a:prstGeom prst="rect">
@@ -3603,7 +3603,7 @@
         </p:nvSpPr>
         <p:spPr>
           <a:xfrm>
-            <a:off x="4111200" y="2574000"/>
+            <a:off x="4111200" y="2502000"/>
             <a:ext cx="2102400" cy="180000"/>
           </a:xfrm>
           <a:prstGeom prst="rect">
@@ -3646,7 +3646,7 @@
         </p:nvSpPr>
         <p:spPr>
           <a:xfrm>
-            <a:off x="4147200" y="2577600"/>
+            <a:off x="4147200" y="2505600"/>
             <a:ext cx="2030400" cy="162000"/>
           </a:xfrm>
           <a:prstGeom prst="rect">
@@ -3681,7 +3681,7 @@
         </p:nvSpPr>
         <p:spPr>
           <a:xfrm>
-            <a:off x="1332000" y="2825999"/>
+            <a:off x="1332000" y="2753999"/>
             <a:ext cx="1951200" cy="180000"/>
           </a:xfrm>
           <a:prstGeom prst="rect">
@@ -3724,7 +3724,7 @@
         </p:nvSpPr>
         <p:spPr>
           <a:xfrm>
-            <a:off x="1368000" y="2829599"/>
+            <a:off x="1368000" y="2757599"/>
             <a:ext cx="1879200" cy="162000"/>
           </a:xfrm>
           <a:prstGeom prst="rect">
@@ -3759,7 +3759,7 @@
         </p:nvSpPr>
         <p:spPr>
           <a:xfrm>
-            <a:off x="3355200" y="2825999"/>
+            <a:off x="3355200" y="2753999"/>
             <a:ext cx="2102400" cy="180000"/>
           </a:xfrm>
           <a:prstGeom prst="rect">
@@ -3802,7 +3802,7 @@
         </p:nvSpPr>
         <p:spPr>
           <a:xfrm>
-            <a:off x="3391200" y="2829599"/>
+            <a:off x="3391200" y="2757599"/>
             <a:ext cx="2030400" cy="162000"/>
           </a:xfrm>
           <a:prstGeom prst="rect">
@@ -3837,7 +3837,7 @@
         </p:nvSpPr>
         <p:spPr>
           <a:xfrm>
-            <a:off x="1332000" y="3077998"/>
+            <a:off x="1332000" y="3005998"/>
             <a:ext cx="1497600" cy="180000"/>
           </a:xfrm>
           <a:prstGeom prst="rect">
@@ -3880,7 +3880,7 @@
         </p:nvSpPr>
         <p:spPr>
           <a:xfrm>
-            <a:off x="1368000" y="3081598"/>
+            <a:off x="1368000" y="3009598"/>
             <a:ext cx="1425600" cy="162000"/>
           </a:xfrm>
           <a:prstGeom prst="rect">
@@ -3915,7 +3915,7 @@
         </p:nvSpPr>
         <p:spPr>
           <a:xfrm>
-            <a:off x="540000" y="3383998"/>
+            <a:off x="540000" y="3419998"/>
             <a:ext cx="648000" cy="180000"/>
           </a:xfrm>
           <a:prstGeom prst="rect">
@@ -3950,7 +3950,7 @@
         </p:nvSpPr>
         <p:spPr>
           <a:xfrm>
-            <a:off x="1332000" y="3653997"/>
+            <a:off x="1332000" y="3689997"/>
             <a:ext cx="6184800" cy="180000"/>
           </a:xfrm>
           <a:prstGeom prst="rect">
@@ -3993,7 +3993,7 @@
         </p:nvSpPr>
         <p:spPr>
           <a:xfrm>
-            <a:off x="1368000" y="3657597"/>
+            <a:off x="1368000" y="3693597"/>
             <a:ext cx="6112800" cy="162000"/>
           </a:xfrm>
           <a:prstGeom prst="rect">
@@ -4028,7 +4028,7 @@
         </p:nvSpPr>
         <p:spPr>
           <a:xfrm>
-            <a:off x="1332000" y="3905996"/>
+            <a:off x="1332000" y="3941996"/>
             <a:ext cx="2102400" cy="180000"/>
           </a:xfrm>
           <a:prstGeom prst="rect">
@@ -4071,7 +4071,7 @@
         </p:nvSpPr>
         <p:spPr>
           <a:xfrm>
-            <a:off x="1368000" y="3909596"/>
+            <a:off x="1368000" y="3945596"/>
             <a:ext cx="2030400" cy="162000"/>
           </a:xfrm>
           <a:prstGeom prst="rect">
@@ -4106,7 +4106,7 @@
         </p:nvSpPr>
         <p:spPr>
           <a:xfrm>
-            <a:off x="3506400" y="3905996"/>
+            <a:off x="3506400" y="3941996"/>
             <a:ext cx="3463200" cy="180000"/>
           </a:xfrm>
           <a:prstGeom prst="rect">
@@ -4149,7 +4149,7 @@
         </p:nvSpPr>
         <p:spPr>
           <a:xfrm>
-            <a:off x="3542400" y="3909596"/>
+            <a:off x="3542400" y="3945596"/>
             <a:ext cx="3391200" cy="162000"/>
           </a:xfrm>
           <a:prstGeom prst="rect">
@@ -4184,7 +4184,7 @@
         </p:nvSpPr>
         <p:spPr>
           <a:xfrm>
-            <a:off x="1332000" y="4157995"/>
+            <a:off x="1332000" y="4193995"/>
             <a:ext cx="2858400" cy="180000"/>
           </a:xfrm>
           <a:prstGeom prst="rect">
@@ -4227,7 +4227,7 @@
         </p:nvSpPr>
         <p:spPr>
           <a:xfrm>
-            <a:off x="1368000" y="4161595"/>
+            <a:off x="1368000" y="4197595"/>
             <a:ext cx="2786400" cy="162000"/>
           </a:xfrm>
           <a:prstGeom prst="rect">
@@ -4262,7 +4262,7 @@
         </p:nvSpPr>
         <p:spPr>
           <a:xfrm>
-            <a:off x="540000" y="4571995"/>
+            <a:off x="540000" y="4787995"/>
             <a:ext cx="54000" cy="251999"/>
           </a:xfrm>
           <a:prstGeom prst="rect">
@@ -4305,7 +4305,7 @@
         </p:nvSpPr>
         <p:spPr>
           <a:xfrm>
-            <a:off x="684000" y="4589995"/>
+            <a:off x="684000" y="4805995"/>
             <a:ext cx="6480000" cy="216000"/>
           </a:xfrm>
           <a:prstGeom prst="rect">
@@ -4340,7 +4340,7 @@
         </p:nvSpPr>
         <p:spPr>
           <a:xfrm>
-            <a:off x="540000" y="4895995"/>
+            <a:off x="540000" y="5111995"/>
             <a:ext cx="6480000" cy="180000"/>
           </a:xfrm>
           <a:prstGeom prst="rect">
@@ -4375,7 +4375,7 @@
         </p:nvSpPr>
         <p:spPr>
           <a:xfrm>
-            <a:off x="540000" y="5075995"/>
+            <a:off x="540000" y="5291995"/>
             <a:ext cx="6480000" cy="144000"/>
           </a:xfrm>
           <a:prstGeom prst="rect">
@@ -4410,7 +4410,7 @@
         </p:nvSpPr>
         <p:spPr>
           <a:xfrm>
-            <a:off x="648000" y="5255995"/>
+            <a:off x="648000" y="5471995"/>
             <a:ext cx="6372000" cy="2088000"/>
           </a:xfrm>
           <a:prstGeom prst="rect">
@@ -4508,7 +4508,7 @@
         </p:nvSpPr>
         <p:spPr>
           <a:xfrm>
-            <a:off x="540000" y="7343995"/>
+            <a:off x="540000" y="7559995"/>
             <a:ext cx="6480000" cy="180000"/>
           </a:xfrm>
           <a:prstGeom prst="rect">
@@ -4543,7 +4543,7 @@
         </p:nvSpPr>
         <p:spPr>
           <a:xfrm>
-            <a:off x="540000" y="7523995"/>
+            <a:off x="540000" y="7739995"/>
             <a:ext cx="6480000" cy="144000"/>
           </a:xfrm>
           <a:prstGeom prst="rect">
@@ -4578,7 +4578,7 @@
         </p:nvSpPr>
         <p:spPr>
           <a:xfrm>
-            <a:off x="648000" y="7703995"/>
+            <a:off x="648000" y="7919995"/>
             <a:ext cx="6372000" cy="1512000"/>
           </a:xfrm>
           <a:prstGeom prst="rect">
@@ -4672,8 +4672,8 @@
         </p:nvSpPr>
         <p:spPr>
           <a:xfrm>
-            <a:off x="540000" y="0"/>
-            <a:ext cx="6480000" cy="180000"/>
+            <a:off x="540000" y="144000"/>
+            <a:ext cx="6480000" cy="144000"/>
           </a:xfrm>
           <a:prstGeom prst="rect">
             <a:avLst/>
@@ -4686,15 +4686,15 @@
           </a:bodyPr>
           <a:lstStyle/>
           <a:p>
-            <a:pPr algn="l">
-              <a:defRPr sz="1300" b="1">
-                <a:solidFill>
-                  <a:srgbClr val="1A1A1A"/>
+            <a:pPr algn="r">
+              <a:defRPr sz="900" b="0">
+                <a:solidFill>
+                  <a:srgbClr val="888888"/>
                 </a:solidFill>
               </a:defRPr>
             </a:pPr>
             <a:r>
-              <a:t>AIGC技术应用与行业实践  |  </a:t>
+              <a:t>（续）</a:t>
             </a:r>
           </a:p>
         </p:txBody>
@@ -4707,8 +4707,8 @@
         </p:nvSpPr>
         <p:spPr>
           <a:xfrm>
-            <a:off x="540000" y="180000"/>
-            <a:ext cx="6480000" cy="144000"/>
+            <a:off x="540000" y="432000"/>
+            <a:ext cx="6480000" cy="180000"/>
           </a:xfrm>
           <a:prstGeom prst="rect">
             <a:avLst/>
@@ -4722,14 +4722,14 @@
           <a:lstStyle/>
           <a:p>
             <a:pPr algn="l">
-              <a:defRPr sz="1000" b="0">
-                <a:solidFill>
-                  <a:srgbClr val="5A9A5A"/>
+              <a:defRPr sz="1300" b="1">
+                <a:solidFill>
+                  <a:srgbClr val="1A1A1A"/>
                 </a:solidFill>
               </a:defRPr>
             </a:pPr>
             <a:r>
-              <a:t>2022.12-2023.12</a:t>
+              <a:t>AIGC技术应用与行业实践  |  </a:t>
             </a:r>
           </a:p>
         </p:txBody>
@@ -4742,7 +4742,42 @@
         </p:nvSpPr>
         <p:spPr>
           <a:xfrm>
-            <a:off x="648000" y="360000"/>
+            <a:off x="540000" y="612000"/>
+            <a:ext cx="6480000" cy="144000"/>
+          </a:xfrm>
+          <a:prstGeom prst="rect">
+            <a:avLst/>
+          </a:prstGeom>
+          <a:noFill/>
+        </p:spPr>
+        <p:txBody>
+          <a:bodyPr wrap="square">
+            <a:spAutoFit/>
+          </a:bodyPr>
+          <a:lstStyle/>
+          <a:p>
+            <a:pPr algn="l">
+              <a:defRPr sz="1000" b="0">
+                <a:solidFill>
+                  <a:srgbClr val="5A9A5A"/>
+                </a:solidFill>
+              </a:defRPr>
+            </a:pPr>
+            <a:r>
+              <a:t>2022.12-2023.12</a:t>
+            </a:r>
+          </a:p>
+        </p:txBody>
+      </p:sp>
+      <p:sp>
+        <p:nvSpPr>
+          <p:cNvPr id="5" name="TextBox 4"/>
+          <p:cNvSpPr txBox="1"/>
+          <p:nvPr/>
+        </p:nvSpPr>
+        <p:spPr>
+          <a:xfrm>
+            <a:off x="648000" y="792000"/>
             <a:ext cx="6372000" cy="1512000"/>
           </a:xfrm>
           <a:prstGeom prst="rect">
@@ -4804,13 +4839,13 @@
       </p:sp>
       <p:sp>
         <p:nvSpPr>
-          <p:cNvPr id="5" name="Rectangle 4"/>
+          <p:cNvPr id="6" name="Rectangle 5"/>
           <p:cNvSpPr/>
           <p:nvPr/>
         </p:nvSpPr>
         <p:spPr>
           <a:xfrm>
-            <a:off x="540000" y="1872000"/>
+            <a:off x="540000" y="2304000"/>
             <a:ext cx="54000" cy="251999"/>
           </a:xfrm>
           <a:prstGeom prst="rect">
@@ -4847,13 +4882,13 @@
       </p:sp>
       <p:sp>
         <p:nvSpPr>
-          <p:cNvPr id="6" name="TextBox 5"/>
+          <p:cNvPr id="7" name="TextBox 6"/>
           <p:cNvSpPr txBox="1"/>
           <p:nvPr/>
         </p:nvSpPr>
         <p:spPr>
           <a:xfrm>
-            <a:off x="684000" y="1890000"/>
+            <a:off x="684000" y="2322000"/>
             <a:ext cx="6480000" cy="216000"/>
           </a:xfrm>
           <a:prstGeom prst="rect">
@@ -4882,13 +4917,13 @@
       </p:sp>
       <p:sp>
         <p:nvSpPr>
-          <p:cNvPr id="7" name="TextBox 6"/>
+          <p:cNvPr id="8" name="TextBox 7"/>
           <p:cNvSpPr txBox="1"/>
           <p:nvPr/>
         </p:nvSpPr>
         <p:spPr>
           <a:xfrm>
-            <a:off x="540000" y="2196000"/>
+            <a:off x="540000" y="2628000"/>
             <a:ext cx="6480000" cy="180000"/>
           </a:xfrm>
           <a:prstGeom prst="rect">
@@ -4917,13 +4952,13 @@
       </p:sp>
       <p:sp>
         <p:nvSpPr>
-          <p:cNvPr id="8" name="TextBox 7"/>
+          <p:cNvPr id="9" name="TextBox 8"/>
           <p:cNvSpPr txBox="1"/>
           <p:nvPr/>
         </p:nvSpPr>
         <p:spPr>
           <a:xfrm>
-            <a:off x="648000" y="2376000"/>
+            <a:off x="648000" y="2808000"/>
             <a:ext cx="6372000" cy="1295999"/>
           </a:xfrm>
           <a:prstGeom prst="rect">
@@ -4985,13 +5020,13 @@
       </p:sp>
       <p:sp>
         <p:nvSpPr>
-          <p:cNvPr id="9" name="TextBox 8"/>
+          <p:cNvPr id="10" name="TextBox 9"/>
           <p:cNvSpPr txBox="1"/>
           <p:nvPr/>
         </p:nvSpPr>
         <p:spPr>
           <a:xfrm>
-            <a:off x="540000" y="3671999"/>
+            <a:off x="540000" y="4103999"/>
             <a:ext cx="6480000" cy="180000"/>
           </a:xfrm>
           <a:prstGeom prst="rect">
@@ -5020,13 +5055,13 @@
       </p:sp>
       <p:sp>
         <p:nvSpPr>
-          <p:cNvPr id="10" name="TextBox 9"/>
+          <p:cNvPr id="11" name="TextBox 10"/>
           <p:cNvSpPr txBox="1"/>
           <p:nvPr/>
         </p:nvSpPr>
         <p:spPr>
           <a:xfrm>
-            <a:off x="648000" y="3851999"/>
+            <a:off x="648000" y="4283999"/>
             <a:ext cx="6372000" cy="1295999"/>
           </a:xfrm>
           <a:prstGeom prst="rect">
@@ -5088,13 +5123,13 @@
       </p:sp>
       <p:sp>
         <p:nvSpPr>
-          <p:cNvPr id="11" name="TextBox 10"/>
+          <p:cNvPr id="12" name="TextBox 11"/>
           <p:cNvSpPr txBox="1"/>
           <p:nvPr/>
         </p:nvSpPr>
         <p:spPr>
           <a:xfrm>
-            <a:off x="540000" y="5147998"/>
+            <a:off x="540000" y="5579998"/>
             <a:ext cx="6480000" cy="180000"/>
           </a:xfrm>
           <a:prstGeom prst="rect">
@@ -5123,13 +5158,13 @@
       </p:sp>
       <p:sp>
         <p:nvSpPr>
-          <p:cNvPr id="12" name="TextBox 11"/>
+          <p:cNvPr id="13" name="TextBox 12"/>
           <p:cNvSpPr txBox="1"/>
           <p:nvPr/>
         </p:nvSpPr>
         <p:spPr>
           <a:xfrm>
-            <a:off x="648000" y="5327998"/>
+            <a:off x="648000" y="5759998"/>
             <a:ext cx="6372000" cy="1044000"/>
           </a:xfrm>
           <a:prstGeom prst="rect">
@@ -5176,13 +5211,13 @@
       </p:sp>
       <p:sp>
         <p:nvSpPr>
-          <p:cNvPr id="13" name="Rectangle 12"/>
+          <p:cNvPr id="14" name="Rectangle 13"/>
           <p:cNvSpPr/>
           <p:nvPr/>
         </p:nvSpPr>
         <p:spPr>
           <a:xfrm>
-            <a:off x="540000" y="6371998"/>
+            <a:off x="540000" y="6803998"/>
             <a:ext cx="54000" cy="251999"/>
           </a:xfrm>
           <a:prstGeom prst="rect">
@@ -5219,13 +5254,13 @@
       </p:sp>
       <p:sp>
         <p:nvSpPr>
-          <p:cNvPr id="14" name="TextBox 13"/>
+          <p:cNvPr id="15" name="TextBox 14"/>
           <p:cNvSpPr txBox="1"/>
           <p:nvPr/>
         </p:nvSpPr>
         <p:spPr>
           <a:xfrm>
-            <a:off x="684000" y="6389998"/>
+            <a:off x="684000" y="6821998"/>
             <a:ext cx="6480000" cy="216000"/>
           </a:xfrm>
           <a:prstGeom prst="rect">
@@ -5254,13 +5289,13 @@
       </p:sp>
       <p:sp>
         <p:nvSpPr>
-          <p:cNvPr id="15" name="TextBox 14"/>
+          <p:cNvPr id="16" name="TextBox 15"/>
           <p:cNvSpPr txBox="1"/>
           <p:nvPr/>
         </p:nvSpPr>
         <p:spPr>
           <a:xfrm>
-            <a:off x="540000" y="6695998"/>
+            <a:off x="540000" y="7127998"/>
             <a:ext cx="6480000" cy="180000"/>
           </a:xfrm>
           <a:prstGeom prst="rect">
@@ -5289,13 +5324,13 @@
       </p:sp>
       <p:sp>
         <p:nvSpPr>
-          <p:cNvPr id="16" name="Rectangle 15"/>
+          <p:cNvPr id="17" name="Rectangle 16"/>
           <p:cNvSpPr/>
           <p:nvPr/>
         </p:nvSpPr>
         <p:spPr>
           <a:xfrm>
-            <a:off x="540000" y="6983998"/>
+            <a:off x="540000" y="7415998"/>
             <a:ext cx="54000" cy="251999"/>
           </a:xfrm>
           <a:prstGeom prst="rect">
@@ -5332,13 +5367,13 @@
       </p:sp>
       <p:sp>
         <p:nvSpPr>
-          <p:cNvPr id="17" name="TextBox 16"/>
+          <p:cNvPr id="18" name="TextBox 17"/>
           <p:cNvSpPr txBox="1"/>
           <p:nvPr/>
         </p:nvSpPr>
         <p:spPr>
           <a:xfrm>
-            <a:off x="684000" y="7001998"/>
+            <a:off x="684000" y="7433998"/>
             <a:ext cx="6480000" cy="216000"/>
           </a:xfrm>
           <a:prstGeom prst="rect">
@@ -5367,13 +5402,13 @@
       </p:sp>
       <p:sp>
         <p:nvSpPr>
-          <p:cNvPr id="18" name="TextBox 17"/>
+          <p:cNvPr id="19" name="TextBox 18"/>
           <p:cNvSpPr txBox="1"/>
           <p:nvPr/>
         </p:nvSpPr>
         <p:spPr>
           <a:xfrm>
-            <a:off x="540000" y="7307998"/>
+            <a:off x="540000" y="7739998"/>
             <a:ext cx="6480000" cy="216000"/>
           </a:xfrm>
           <a:prstGeom prst="rect">
@@ -5399,13 +5434,13 @@
       </p:sp>
       <p:sp>
         <p:nvSpPr>
-          <p:cNvPr id="19" name="Rectangle 18"/>
+          <p:cNvPr id="20" name="Rectangle 19"/>
           <p:cNvSpPr/>
           <p:nvPr/>
         </p:nvSpPr>
         <p:spPr>
           <a:xfrm>
-            <a:off x="540000" y="7667998"/>
+            <a:off x="540000" y="8099998"/>
             <a:ext cx="54000" cy="251999"/>
           </a:xfrm>
           <a:prstGeom prst="rect">
@@ -5442,13 +5477,13 @@
       </p:sp>
       <p:sp>
         <p:nvSpPr>
-          <p:cNvPr id="20" name="TextBox 19"/>
+          <p:cNvPr id="21" name="TextBox 20"/>
           <p:cNvSpPr txBox="1"/>
           <p:nvPr/>
         </p:nvSpPr>
         <p:spPr>
           <a:xfrm>
-            <a:off x="684000" y="7685998"/>
+            <a:off x="684000" y="8117998"/>
             <a:ext cx="6480000" cy="216000"/>
           </a:xfrm>
           <a:prstGeom prst="rect">
@@ -5477,13 +5512,13 @@
       </p:sp>
       <p:sp>
         <p:nvSpPr>
-          <p:cNvPr id="21" name="TextBox 20"/>
+          <p:cNvPr id="22" name="TextBox 21"/>
           <p:cNvSpPr txBox="1"/>
           <p:nvPr/>
         </p:nvSpPr>
         <p:spPr>
           <a:xfrm>
-            <a:off x="540000" y="7991998"/>
+            <a:off x="540000" y="8423998"/>
             <a:ext cx="6480000" cy="540000"/>
           </a:xfrm>
           <a:prstGeom prst="rect">
@@ -5545,7 +5580,7 @@
       </p:sp>
       <p:sp>
         <p:nvSpPr>
-          <p:cNvPr id="22" name="TextBox 21"/>
+          <p:cNvPr id="23" name="TextBox 22"/>
           <p:cNvSpPr txBox="1"/>
           <p:nvPr/>
         </p:nvSpPr>

</xml_diff>